<commit_message>
Solution brief: plain-language wording and a glossary slide
</commit_message>
<xml_diff>
--- a/project_context/Triage_Solution_Brief.pptx
+++ b/project_context/Triage_Solution_Brief.pptx
@@ -21,9 +21,10 @@
     <p:sldId id="269" r:id="rId15"/>
     <p:sldId id="270" r:id="rId16"/>
     <p:sldId id="271" r:id="rId17"/>
+    <p:sldId id="272" r:id="rId18"/>
   </p:sldIdLst>
   <p:notesMasterIdLst>
-    <p:notesMasterId r:id="rId18"/>
+    <p:notesMasterId r:id="rId19"/>
   </p:notesMasterIdLst>
   <p:sldSz cx="12192000" cy="6858000"/>
   <p:notesSz cx="6858000" cy="12192000"/>
@@ -122,7 +123,7 @@
   <p:extLst>
     <p:ext uri="{521415D9-36F7-43E2-AB2F-B90AF26B5E84}">
       <p14:sectionLst xmlns:p14="http://schemas.microsoft.com/office/powerpoint/2010/main">
-        <p14:section name="Overview" id="{532fc5b0-8a89-7a0b-b87a-ebb41d29cc55}">
+        <p14:section name="Overview" id="{82a6318e-0fee-d3e1-c1bd-a583efff2ef1}">
           <p14:sldIdLst>
             <p14:sldId id="256"/>
             <p14:sldId id="257"/>
@@ -130,7 +131,7 @@
             <p14:sldId id="259"/>
           </p14:sldIdLst>
         </p14:section>
-        <p14:section name="Design" id="{71b6d116-5b9d-759b-5901-abbdadd5a83b}">
+        <p14:section name="Design" id="{27d27831-304d-104e-df9b-1884ac3884f2}">
           <p14:sldIdLst>
             <p14:sldId id="260"/>
             <p14:sldId id="261"/>
@@ -139,19 +140,20 @@
             <p14:sldId id="264"/>
           </p14:sldIdLst>
         </p14:section>
-        <p14:section name="Evidence" id="{32cc59c6-40b2-31fe-e354-2e586783b2d4}">
+        <p14:section name="Evidence" id="{6e684f45-5481-843b-7550-f26484880ebe}">
           <p14:sldIdLst>
             <p14:sldId id="265"/>
             <p14:sldId id="266"/>
             <p14:sldId id="267"/>
           </p14:sldIdLst>
         </p14:section>
-        <p14:section name="Judgement" id="{279548e3-ab7f-3245-80f2-9fb58b774e5c}">
+        <p14:section name="Judgement" id="{717e45bd-9131-c968-4ec8-afeea616d3c1}">
           <p14:sldIdLst>
             <p14:sldId id="268"/>
             <p14:sldId id="269"/>
             <p14:sldId id="270"/>
             <p14:sldId id="271"/>
+            <p14:sldId id="272"/>
           </p14:sldIdLst>
         </p14:section>
       </p14:sectionLst>
@@ -230,10 +232,10 @@
                     <c:v>Triage model</c:v>
                   </c:pt>
                   <c:pt idx="1">
-                    <c:v>Rules (RAG)</c:v>
+                    <c:v>Red/yellow/green rules</c:v>
                   </c:pt>
                   <c:pt idx="2">
-                    <c:v>ARR + renewal date</c:v>
+                    <c:v>Revenue + renewal date</c:v>
                   </c:pt>
                   <c:pt idx="3">
                     <c:v>Perfect foresight</c:v>
@@ -273,7 +275,7 @@
               <c:strCache>
                 <c:ptCount val="1"/>
                 <c:pt idx="0">
-                  <c:v>Churned ARR listed early</c:v>
+                  <c:v>Lost revenue listed early</c:v>
                 </c:pt>
               </c:strCache>
             </c:strRef>
@@ -319,10 +321,10 @@
                     <c:v>Triage model</c:v>
                   </c:pt>
                   <c:pt idx="1">
-                    <c:v>Rules (RAG)</c:v>
+                    <c:v>Red/yellow/green rules</c:v>
                   </c:pt>
                   <c:pt idx="2">
-                    <c:v>ARR + renewal date</c:v>
+                    <c:v>Revenue + renewal date</c:v>
                   </c:pt>
                   <c:pt idx="3">
                     <c:v>Perfect foresight</c:v>
@@ -1520,7 +1522,7 @@
           <a:p>
             <a:r>
               <a:rPr lang="en-US" dirty="0"/>
-              <a:t>I'd want answers to these four questions before tuning anything further, because they change the label and the thresholds. The next engineering step is a same-day interrupt for critical events, layered on top of the nightly run rather than replacing it, since the nightly reconcile is needed anyway.</a:t>
+              <a:t>A reference slide; I won't present it, but it's here so every term in the deck has a plain-language meaning.</a:t>
             </a:r>
             <a:endParaRPr lang="en-US" dirty="0"/>
           </a:p>
@@ -1544,6 +1546,94 @@
             <a:fld id="{F7021451-1387-4CA6-816F-3879F97B5CBC}" type="slidenum">
               <a:rPr lang="en-US"/>
               <a:t>16</a:t>
+            </a:fld>
+            <a:endParaRPr lang="en-US"/>
+          </a:p>
+        </p:txBody>
+      </p:sp>
+    </p:spTree>
+    <p:extLst>
+      <p:ext uri="{BB962C8B-B14F-4D97-AF65-F5344CB8AC3E}">
+        <p14:creationId xmlns:p14="http://schemas.microsoft.com/office/powerpoint/2010/main" val="1024086991"/>
+      </p:ext>
+    </p:extLst>
+  </p:cSld>
+  <p:clrMapOvr>
+    <a:masterClrMapping/>
+  </p:clrMapOvr>
+</p:notes>
+</file>
+
+<file path=ppt/notesSlides/notesSlide17.xml><?xml version="1.0" encoding="utf-8"?>
+<p:notes xmlns:a="http://schemas.openxmlformats.org/drawingml/2006/main" xmlns:r="http://schemas.openxmlformats.org/officeDocument/2006/relationships" xmlns:p="http://schemas.openxmlformats.org/presentationml/2006/main">
+  <p:cSld>
+    <p:spTree>
+      <p:nvGrpSpPr>
+        <p:cNvPr id="1" name=""/>
+        <p:cNvGrpSpPr/>
+        <p:nvPr/>
+      </p:nvGrpSpPr>
+      <p:grpSpPr>
+        <a:xfrm>
+          <a:off x="0" y="0"/>
+          <a:ext cx="0" cy="0"/>
+          <a:chOff x="0" y="0"/>
+          <a:chExt cx="0" cy="0"/>
+        </a:xfrm>
+      </p:grpSpPr>
+      <p:sp>
+        <p:nvSpPr>
+          <p:cNvPr id="2" name="Slide Image Placeholder 1"/>
+          <p:cNvSpPr>
+            <a:spLocks noGrp="1" noRot="1" noChangeAspect="1"/>
+          </p:cNvSpPr>
+          <p:nvPr>
+            <p:ph type="sldImg"/>
+          </p:nvPr>
+        </p:nvSpPr>
+        <p:spPr/>
+      </p:sp>
+      <p:sp>
+        <p:nvSpPr>
+          <p:cNvPr id="3" name="Notes Placeholder 2"/>
+          <p:cNvSpPr>
+            <a:spLocks noGrp="1"/>
+          </p:cNvSpPr>
+          <p:nvPr>
+            <p:ph type="body" idx="1"/>
+          </p:nvPr>
+        </p:nvSpPr>
+        <p:spPr/>
+        <p:txBody>
+          <a:bodyPr/>
+          <a:lstStyle/>
+          <a:p>
+            <a:r>
+              <a:rPr lang="en-US" dirty="0"/>
+              <a:t>I'd want answers to these four questions before tuning anything further, because they change the label and the thresholds. The next engineering step is a same-day interrupt for critical events, layered on top of the nightly run rather than replacing it, since the nightly reconcile is needed anyway.</a:t>
+            </a:r>
+            <a:endParaRPr lang="en-US" dirty="0"/>
+          </a:p>
+        </p:txBody>
+      </p:sp>
+      <p:sp>
+        <p:nvSpPr>
+          <p:cNvPr id="4" name="Slide Number Placeholder 3"/>
+          <p:cNvSpPr>
+            <a:spLocks noGrp="1"/>
+          </p:cNvSpPr>
+          <p:nvPr>
+            <p:ph type="sldNum" sz="quarter" idx="10"/>
+          </p:nvPr>
+        </p:nvSpPr>
+        <p:spPr/>
+        <p:txBody>
+          <a:bodyPr/>
+          <a:lstStyle/>
+          <a:p>
+            <a:fld id="{F7021451-1387-4CA6-816F-3879F97B5CBC}" type="slidenum">
+              <a:rPr lang="en-US"/>
+              <a:t>17</a:t>
             </a:fld>
             <a:endParaRPr lang="en-US"/>
           </a:p>
@@ -3667,7 +3757,7 @@
                   <a:schemeClr val="accent5"/>
                 </a:solidFill>
               </a:rPr>
-              <a:t>Judged on a replay of the weekly call list, not only on AUC: the decision is who fills 15 slots each week</a:t>
+              <a:t>Judged by replaying the weekly call list: the real decision is who fills a CSM's 15 slots each week</a:t>
             </a:r>
             <a:endParaRPr lang="en-US" sz="1600" dirty="0"/>
           </a:p>
@@ -3719,7 +3809,7 @@
                   <a:schemeClr val="tx2"/>
                 </a:solidFill>
               </a:rPr>
-              <a:t>Ranking</a:t>
+              <a:t>Ranking accuracy</a:t>
             </a:r>
             <a:endParaRPr lang="en-US" sz="1500" dirty="0"/>
           </a:p>
@@ -3755,7 +3845,7 @@
                   <a:schemeClr val="tx1"/>
                 </a:solidFill>
               </a:rPr>
-              <a:t>ROC AUC 0.75 · PR AUC 0.29 at a 9.8% base rate (3× lift). Per company 0.79 / 0.75 / 0.69</a:t>
+              <a:t>0.75 vs 0.59 for rules (0.5 = coin flip). Finds churners about 3× better than random</a:t>
             </a:r>
             <a:endParaRPr lang="en-US" sz="1300" dirty="0"/>
           </a:p>
@@ -3791,7 +3881,7 @@
                   <a:schemeClr val="tx2"/>
                 </a:solidFill>
               </a:rPr>
-              <a:t>Calibration</a:t>
+              <a:t>Honest percentages</a:t>
             </a:r>
             <a:endParaRPr lang="en-US" sz="1500" dirty="0"/>
           </a:p>
@@ -3827,7 +3917,7 @@
                   <a:schemeClr val="tx1"/>
                 </a:solidFill>
               </a:rPr>
-              <a:t>Predicted and observed churn match within a few points per decile, per company</a:t>
+              <a:t>When it says 20%, about 1 in 5 of those accounts really don't renew</a:t>
             </a:r>
             <a:endParaRPr lang="en-US" sz="1300" dirty="0"/>
           </a:p>
@@ -3863,7 +3953,7 @@
                   <a:schemeClr val="tx2"/>
                 </a:solidFill>
               </a:rPr>
-              <a:t>Baselines</a:t>
+              <a:t>Fair comparison</a:t>
             </a:r>
             <a:endParaRPr lang="en-US" sz="1500" dirty="0"/>
           </a:p>
@@ -3899,7 +3989,7 @@
                   <a:schemeClr val="tx1"/>
                 </a:solidFill>
               </a:rPr>
-              <a:t>Rules score and today's ARR + date ordering, at the same capacity</a:t>
+              <a:t>Same 15 slots per CSM for every method; only the risk estimate changes</a:t>
             </a:r>
             <a:endParaRPr lang="en-US" sz="1300" dirty="0"/>
           </a:p>
@@ -3935,7 +4025,7 @@
                   <a:schemeClr val="tx2"/>
                 </a:solidFill>
               </a:rPr>
-              <a:t>Ceiling</a:t>
+              <a:t>Hit rate</a:t>
             </a:r>
             <a:endParaRPr lang="en-US" sz="1500" dirty="0"/>
           </a:p>
@@ -3971,7 +4061,7 @@
                   <a:schemeClr val="tx1"/>
                 </a:solidFill>
               </a:rPr>
-              <a:t>Precision 9.4% vs 16% with perfect foresight</a:t>
+              <a:t>9.4% of call slots were real churners; even perfect foresight gets only 16%</a:t>
             </a:r>
             <a:endParaRPr lang="en-US" sz="1300" dirty="0"/>
           </a:p>
@@ -4007,7 +4097,7 @@
                   <a:schemeClr val="tx2"/>
                 </a:solidFill>
               </a:rPr>
-              <a:t>Stories</a:t>
+              <a:t>Real cases</a:t>
             </a:r>
             <a:endParaRPr lang="en-US" sz="1500" dirty="0"/>
           </a:p>
@@ -4043,7 +4133,7 @@
                   <a:schemeClr val="tx1"/>
                 </a:solidFill>
               </a:rPr>
-              <a:t>Kestrel listed 105 days early; rules never</a:t>
+              <a:t>Kestrel listed 105 days early; the rules never listed it</a:t>
             </a:r>
             <a:endParaRPr lang="en-US" sz="1300" dirty="0"/>
           </a:p>
@@ -4252,7 +4342,7 @@
                   <a:schemeClr val="tx2"/>
                 </a:solidFill>
               </a:rPr>
-              <a:t>ingest</a:t>
+              <a:t>load new data</a:t>
             </a:r>
             <a:endParaRPr lang="en-US" sz="1400" dirty="0"/>
           </a:p>
@@ -4339,7 +4429,7 @@
                   <a:schemeClr val="tx2"/>
                 </a:solidFill>
               </a:rPr>
-              <a:t>identity</a:t>
+              <a:t>match records</a:t>
             </a:r>
             <a:endParaRPr lang="en-US" sz="1400" dirty="0"/>
           </a:p>
@@ -4513,7 +4603,7 @@
                   <a:schemeClr val="tx2"/>
                 </a:solidFill>
               </a:rPr>
-              <a:t>load data</a:t>
+              <a:t>build signals</a:t>
             </a:r>
             <a:endParaRPr lang="en-US" sz="1400" dirty="0"/>
           </a:p>
@@ -4687,7 +4777,7 @@
                   <a:schemeClr val="tx2"/>
                 </a:solidFill>
               </a:rPr>
-              <a:t>persist scores</a:t>
+              <a:t>save scores</a:t>
             </a:r>
             <a:endParaRPr lang="en-US" sz="1400" dirty="0"/>
           </a:p>
@@ -4774,7 +4864,7 @@
                   <a:schemeClr val="bg1"/>
                 </a:solidFill>
               </a:rPr>
-              <a:t>briefs</a:t>
+              <a:t>write notes</a:t>
             </a:r>
             <a:endParaRPr lang="en-US" sz="1400" dirty="0"/>
           </a:p>
@@ -4810,7 +4900,7 @@
                   <a:schemeClr val="accent5"/>
                 </a:solidFill>
               </a:rPr>
-              <a:t>Each step is timed and logged; the run writes a heartbeat; briefs are saved in batches of 50</a:t>
+              <a:t>Each step is timed and logged; the run reports it is alive every few seconds; notes are saved in batches of 50</a:t>
             </a:r>
             <a:endParaRPr lang="en-US" sz="1300" dirty="0"/>
           </a:p>
@@ -4931,7 +5021,7 @@
                   <a:schemeClr val="tx1"/>
                 </a:solidFill>
               </a:rPr>
-              <a:t>Durable steps and saved briefs are skipped</a:t>
+              <a:t>Steps already done, and notes already written, are skipped</a:t>
             </a:r>
             <a:endParaRPr lang="en-US" sz="1400" dirty="0"/>
           </a:p>
@@ -5052,7 +5142,7 @@
                   <a:schemeClr val="tx1"/>
                 </a:solidFill>
               </a:rPr>
-              <a:t>Per-company Postgres lock: never two runs at once</a:t>
+              <a:t>A database lock per company: never two runs at once</a:t>
             </a:r>
             <a:endParaRPr lang="en-US" sz="1400" dirty="0"/>
           </a:p>
@@ -5088,7 +5178,7 @@
                   <a:schemeClr val="tx1"/>
                 </a:solidFill>
               </a:rPr>
-              <a:t>06:30 UTC watchdog: stuck runs → abandoned, missing runs started</a:t>
+              <a:t>Morning check (06:30 UTC): closes stuck runs, starts missing ones</a:t>
             </a:r>
             <a:endParaRPr lang="en-US" sz="1400" dirty="0"/>
           </a:p>
@@ -5537,7 +5627,7 @@
                   <a:schemeClr val="bg1"/>
                 </a:solidFill>
               </a:rPr>
-              <a:t>The LLM sees only numbered facts (F*) and events (E*)</a:t>
+              <a:t>The AI writer (LLM) sees only a numbered list of facts</a:t>
             </a:r>
             <a:endParaRPr lang="en-US" sz="1400" dirty="0"/>
           </a:p>
@@ -5773,7 +5863,7 @@
                   <a:schemeClr val="tx1"/>
                 </a:solidFill>
               </a:rPr>
-              <a:t>tenant_id on every row + forced row-level security</a:t>
+              <a:t>Every row is tagged with its company</a:t>
             </a:r>
             <a:endParaRPr lang="en-US" sz="1400" dirty="0"/>
           </a:p>
@@ -5791,7 +5881,7 @@
                   <a:schemeClr val="tx1"/>
                 </a:solidFill>
               </a:rPr>
-              <a:t>Each request runs as a restricted role with the tenant set by the token</a:t>
+              <a:t>The database itself filters to the signed-in user's company</a:t>
             </a:r>
             <a:endParaRPr lang="en-US" sz="1400" dirty="0"/>
           </a:p>
@@ -5809,7 +5899,7 @@
                   <a:schemeClr val="tx1"/>
                 </a:solidFill>
               </a:rPr>
-              <a:t>No tenant set → zero rows: fails closed</a:t>
+              <a:t>If no company is set, it returns nothing (fails safe)</a:t>
             </a:r>
             <a:endParaRPr lang="en-US" sz="1400" dirty="0"/>
           </a:p>
@@ -5827,7 +5917,7 @@
                   <a:schemeClr val="tx1"/>
                 </a:solidFill>
               </a:rPr>
-              <a:t>Model card and audit views are tenant-filtered too</a:t>
+              <a:t>Model and audit pages are filtered per company too</a:t>
             </a:r>
             <a:endParaRPr lang="en-US" sz="1400" dirty="0"/>
           </a:p>
@@ -6009,7 +6099,7 @@
                   <a:schemeClr val="tx1"/>
                 </a:solidFill>
               </a:rPr>
-              <a:t>Score row → run → model version → stored feature values</a:t>
+              <a:t>Each score links to its run, model version and exact inputs</a:t>
             </a:r>
             <a:endParaRPr lang="en-US" sz="1400" dirty="0"/>
           </a:p>
@@ -6045,7 +6135,7 @@
                   <a:schemeClr val="tx1"/>
                 </a:solidFill>
               </a:rPr>
-              <a:t>Late rows are shown, hatched, as unused</a:t>
+              <a:t>Data that arrived after the run is shown, marked unused</a:t>
             </a:r>
             <a:endParaRPr lang="en-US" sz="1400" dirty="0"/>
           </a:p>
@@ -6063,7 +6153,7 @@
                   <a:schemeClr val="tx1"/>
                 </a:solidFill>
               </a:rPr>
-              <a:t>Identity links show method and confidence</a:t>
+              <a:t>Each record-to-account match shows how sure it is</a:t>
             </a:r>
             <a:endParaRPr lang="en-US" sz="1400" dirty="0"/>
           </a:p>
@@ -6081,7 +6171,7 @@
                   <a:schemeClr val="tx1"/>
                 </a:solidFill>
               </a:rPr>
-              <a:t>API audit: user name → trace_id → every log line</a:t>
+              <a:t>Every request is logged: from a user's name to their exact request</a:t>
             </a:r>
             <a:endParaRPr lang="en-US" sz="1400" dirty="0"/>
           </a:p>
@@ -6387,7 +6477,7 @@
                   <a:schemeClr val="accent5"/>
                 </a:solidFill>
               </a:rPr>
-              <a:t>Point-in-time features; replays see what the run saw</a:t>
+              <a:t>Scores use only what had arrived by their date</a:t>
             </a:r>
             <a:endParaRPr lang="en-US" sz="1300" dirty="0"/>
           </a:p>
@@ -6547,7 +6637,7 @@
                   <a:schemeClr val="accent5"/>
                 </a:solidFill>
               </a:rPr>
-              <a:t>File, record-hash and semantic-key idempotency</a:t>
+              <a:t>Detected at three levels; reloading changes nothing</a:t>
             </a:r>
             <a:endParaRPr lang="en-US" sz="1300" dirty="0"/>
           </a:p>
@@ -7027,7 +7117,7 @@
                   <a:schemeClr val="accent5"/>
                 </a:solidFill>
               </a:rPr>
-              <a:t>Anniversary fallback, flagged in the UI</a:t>
+              <a:t>Use the contract anniversary, flagged in the UI</a:t>
             </a:r>
             <a:endParaRPr lang="en-US" sz="1300" dirty="0"/>
           </a:p>
@@ -7347,7 +7437,7 @@
                   <a:schemeClr val="accent5"/>
                 </a:solidFill>
               </a:rPr>
-              <a:t>Heartbeat, one auto-resume, manager Resume</a:t>
+              <a:t>Detected, resumed once automatically, then by a manager</a:t>
             </a:r>
             <a:endParaRPr lang="en-US" sz="1300" dirty="0"/>
           </a:p>
@@ -7507,7 +7597,7 @@
                   <a:schemeClr val="accent5"/>
                 </a:solidFill>
               </a:rPr>
-              <a:t>Per-company advisory lock; API returns 409</a:t>
+              <a:t>A per-company lock; the second request is refused</a:t>
             </a:r>
             <a:endParaRPr lang="en-US" sz="1300" dirty="0"/>
           </a:p>
@@ -7631,7 +7721,7 @@
                   <a:schemeClr val="tx2"/>
                 </a:solidFill>
               </a:rPr>
-              <a:t>Tiny company, few labels</a:t>
+              <a:t>Tiny company, little history</a:t>
             </a:r>
             <a:endParaRPr lang="en-US" sz="1500" dirty="0"/>
           </a:p>
@@ -7667,7 +7757,7 @@
                   <a:schemeClr val="accent5"/>
                 </a:solidFill>
               </a:rPr>
-              <a:t>Pooled model, per-company calibration</a:t>
+              <a:t>Shared model, percentages adjusted per company</a:t>
             </a:r>
             <a:endParaRPr lang="en-US" sz="1300" dirty="0"/>
           </a:p>
@@ -7791,7 +7881,7 @@
                   <a:schemeClr val="tx2"/>
                 </a:solidFill>
               </a:rPr>
-              <a:t>Signal weight points the wrong way</a:t>
+              <a:t>A signal points the wrong way</a:t>
             </a:r>
             <a:endParaRPr lang="en-US" sz="1500" dirty="0"/>
           </a:p>
@@ -7827,7 +7917,7 @@
                   <a:schemeClr val="accent5"/>
                 </a:solidFill>
               </a:rPr>
-              <a:t>Sign-constrained refit; no absurd reasons</a:t>
+              <a:t>Removed and refit, so no absurd reasons are shown</a:t>
             </a:r>
             <a:endParaRPr lang="en-US" sz="1300" dirty="0"/>
           </a:p>
@@ -8382,7 +8472,7 @@
                             <a:schemeClr val="tx2"/>
                           </a:solidFill>
                         </a:rPr>
-                        <a:t>Logistic regression</a:t>
+                        <a:t>Simple model (logistic regression)</a:t>
                       </a:r>
                       <a:endParaRPr lang="en-US" sz="1400" dirty="0"/>
                     </a:p>
@@ -8440,7 +8530,7 @@
                             <a:schemeClr val="accent5"/>
                           </a:solidFill>
                         </a:rPr>
-                        <a:t>Gradient boosting</a:t>
+                        <a:t>Complex model (gradient boosting)</a:t>
                       </a:r>
                       <a:endParaRPr lang="en-US" sz="1400" dirty="0"/>
                     </a:p>
@@ -8498,7 +8588,7 @@
                             <a:schemeClr val="tx1"/>
                           </a:solidFill>
                         </a:rPr>
-                        <a:t>Better on validation and gives exact per-account reasons</a:t>
+                        <a:t>Scored better on validation and explains each account exactly</a:t>
                       </a:r>
                       <a:endParaRPr lang="en-US" sz="1400" dirty="0"/>
                     </a:p>
@@ -8558,7 +8648,7 @@
                             <a:schemeClr val="tx2"/>
                           </a:solidFill>
                         </a:rPr>
-                        <a:t>Pooled model + per-company calibration</a:t>
+                        <a:t>One shared model, adjusted per company</a:t>
                       </a:r>
                       <a:endParaRPr lang="en-US" sz="1400" dirty="0"/>
                     </a:p>
@@ -8674,7 +8764,7 @@
                             <a:schemeClr val="tx1"/>
                           </a:solidFill>
                         </a:rPr>
-                        <a:t>The smallest company has ~100 renewals</a:t>
+                        <a:t>The smallest company has only ~100 renewals</a:t>
                       </a:r>
                       <a:endParaRPr lang="en-US" sz="1400" dirty="0"/>
                     </a:p>
@@ -8850,7 +8940,7 @@
                             <a:schemeClr val="tx1"/>
                           </a:solidFill>
                         </a:rPr>
-                        <a:t>~10% precision; an email can speed up churn</a:t>
+                        <a:t>~10% hit rate; an email can speed up churn</a:t>
                       </a:r>
                       <a:endParaRPr lang="en-US" sz="1400" dirty="0"/>
                     </a:p>
@@ -8910,7 +9000,7 @@
                             <a:schemeClr val="tx2"/>
                           </a:solidFill>
                         </a:rPr>
-                        <a:t>No probability floor on the call list</a:t>
+                        <a:t>No minimum-risk cut-off for the call list</a:t>
                       </a:r>
                       <a:endParaRPr lang="en-US" sz="1400" dirty="0"/>
                     </a:p>
@@ -9026,7 +9116,7 @@
                             <a:schemeClr val="tx1"/>
                           </a:solidFill>
                         </a:rPr>
-                        <a:t>A floor cut churned ARR caught early from 93% to 64%</a:t>
+                        <a:t>A cut-off dropped lost revenue caught early from 93% to 64%</a:t>
                       </a:r>
                       <a:endParaRPr lang="en-US" sz="1400" dirty="0"/>
                     </a:p>
@@ -9262,7 +9352,7 @@
                             <a:schemeClr val="tx2"/>
                           </a:solidFill>
                         </a:rPr>
-                        <a:t>One EC2 + Docker Compose</a:t>
+                        <a:t>One AWS server + Docker Compose</a:t>
                       </a:r>
                       <a:endParaRPr lang="en-US" sz="1400" dirty="0"/>
                     </a:p>
@@ -9320,7 +9410,7 @@
                             <a:schemeClr val="accent5"/>
                           </a:solidFill>
                         </a:rPr>
-                        <a:t>Managed services (ECS, RDS)</a:t>
+                        <a:t>Managed AWS services</a:t>
                       </a:r>
                       <a:endParaRPr lang="en-US" sz="1400" dirty="0"/>
                     </a:p>
@@ -9666,7 +9756,7 @@
                   <a:schemeClr val="tx1"/>
                 </a:solidFill>
               </a:rPr>
-              <a:t>automated tests: RLS, idempotency, traceability, permissions, grounding</a:t>
+              <a:t>automated tests: data isolation, no duplicates, traceability, permissions, AI fact-checks</a:t>
             </a:r>
             <a:endParaRPr lang="en-US" sz="1300" dirty="0"/>
           </a:p>
@@ -9864,7 +9954,7 @@
                   <a:schemeClr val="tx1"/>
                 </a:solidFill>
               </a:rPr>
-              <a:t>account page after indexes and linked-id lookups</a:t>
+              <a:t>account page load time after query tuning</a:t>
             </a:r>
             <a:endParaRPr lang="en-US" sz="1300" dirty="0"/>
           </a:p>
@@ -10102,7 +10192,7 @@
                   <a:schemeClr val="bg1"/>
                 </a:solidFill>
               </a:rPr>
-              <a:t>TLS and security headers at Caddy; only ports 80/443 open</a:t>
+              <a:t>HTTPS and browser security headers; only web ports open</a:t>
             </a:r>
             <a:endParaRPr lang="en-US" sz="1400" dirty="0"/>
           </a:p>
@@ -10138,7 +10228,7 @@
                   <a:schemeClr val="bg1"/>
                 </a:solidFill>
               </a:rPr>
-              <a:t>Migrations applied on start; idempotent one-command bootstrap</a:t>
+              <a:t>Database updates applied on start; one-command, re-runnable setup</a:t>
             </a:r>
             <a:endParaRPr lang="en-US" sz="1400" dirty="0"/>
           </a:p>
@@ -10156,7 +10246,7 @@
                   <a:schemeClr val="bg1"/>
                 </a:solidFill>
               </a:rPr>
-              <a:t>JSON logs carry trace_id, user_name and run_id</a:t>
+              <a:t>Every log line carries the request ID, user and run</a:t>
             </a:r>
             <a:endParaRPr lang="en-US" sz="1400" dirty="0"/>
           </a:p>
@@ -10260,6 +10350,1628 @@
         </p:nvSpPr>
         <p:spPr>
           <a:xfrm>
+            <a:off x="548640" y="320040"/>
+            <a:ext cx="11094415" cy="685800"/>
+          </a:xfrm>
+          <a:prstGeom prst="rect">
+            <a:avLst/>
+          </a:prstGeom>
+          <a:noFill/>
+          <a:ln/>
+        </p:spPr>
+        <p:txBody>
+          <a:bodyPr wrap="square" lIns="0" tIns="0" rIns="0" bIns="0" rtlCol="0" anchor="ctr"/>
+          <a:lstStyle/>
+          <a:p>
+            <a:pPr algn="l" indent="0" marL="0">
+              <a:buNone/>
+            </a:pPr>
+            <a:r>
+              <a:rPr lang="en-US" sz="3200" b="1" dirty="0">
+                <a:solidFill>
+                  <a:schemeClr val="tx2"/>
+                </a:solidFill>
+              </a:rPr>
+              <a:t>Glossary</a:t>
+            </a:r>
+            <a:endParaRPr lang="en-US" sz="3200" dirty="0"/>
+          </a:p>
+        </p:txBody>
+      </p:sp>
+      <p:sp>
+        <p:nvSpPr>
+          <p:cNvPr id="3" name="Text 0"/>
+          <p:cNvSpPr/>
+          <p:nvPr>
+            <p:ph idx="101" type="body" hasCustomPrompt="1"/>
+          </p:nvPr>
+        </p:nvSpPr>
+        <p:spPr>
+          <a:xfrm>
+            <a:off x="548640" y="960120"/>
+            <a:ext cx="11094415" cy="411480"/>
+          </a:xfrm>
+          <a:prstGeom prst="rect">
+            <a:avLst/>
+          </a:prstGeom>
+          <a:noFill/>
+          <a:ln/>
+        </p:spPr>
+        <p:txBody>
+          <a:bodyPr wrap="square" lIns="0" tIns="0" rIns="0" bIns="0" rtlCol="0" anchor="t"/>
+          <a:lstStyle/>
+          <a:p>
+            <a:pPr algn="l" indent="0" marL="0">
+              <a:buNone/>
+            </a:pPr>
+            <a:r>
+              <a:rPr lang="en-US" sz="1600" dirty="0">
+                <a:solidFill>
+                  <a:schemeClr val="accent5"/>
+                </a:solidFill>
+              </a:rPr>
+              <a:t>Terms used in this brief, in plain words</a:t>
+            </a:r>
+            <a:endParaRPr lang="en-US" sz="1600" dirty="0"/>
+          </a:p>
+        </p:txBody>
+      </p:sp>
+      <p:graphicFrame>
+        <p:nvGraphicFramePr>
+          <p:cNvPr id="17" name="table-296"/>
+          <p:cNvGraphicFramePr>
+            <a:graphicFrameLocks noGrp="1"/>
+          </p:cNvGraphicFramePr>
+          <p:nvPr>
+            <p:extLst>
+              <p:ext uri="{D42A27DB-BD31-4B8C-83A1-F6EECF244321}">
+                <p14:modId xmlns:p14="http://schemas.microsoft.com/office/powerpoint/2010/main" val="1579011935"/>
+              </p:ext>
+            </p:extLst>
+          </p:nvPr>
+        </p:nvGraphicFramePr>
+        <p:xfrm>
+          <a:off x="548640" y="1600200"/>
+          <a:ext cx="5410048" cy="914400"/>
+        </p:xfrm>
+        <a:graphic>
+          <a:graphicData uri="http://schemas.openxmlformats.org/drawingml/2006/table">
+            <a:tbl>
+              <a:tblPr/>
+              <a:tblGrid>
+                <a:gridCol w="1783080"/>
+                <a:gridCol w="3626968"/>
+              </a:tblGrid>
+              <a:tr h="713232">
+                <a:tc>
+                  <a:txBody>
+                    <a:bodyPr/>
+                    <a:lstStyle/>
+                    <a:p>
+                      <a:pPr indent="0" marL="0">
+                        <a:buNone/>
+                      </a:pPr>
+                      <a:r>
+                        <a:rPr lang="en-US" sz="1400" b="1" dirty="0">
+                          <a:solidFill>
+                            <a:schemeClr val="tx2"/>
+                          </a:solidFill>
+                        </a:rPr>
+                        <a:t>CSM</a:t>
+                      </a:r>
+                      <a:endParaRPr lang="en-US" sz="1400" dirty="0"/>
+                    </a:p>
+                  </a:txBody>
+                  <a:tcPr marL="101600" marR="101600" marT="38100" marB="38100" anchor="ctr">
+                    <a:lnL w="9525" cap="flat" cmpd="sng" algn="ctr">
+                      <a:solidFill>
+                        <a:srgbClr val="DDE4F0"/>
+                      </a:solidFill>
+                      <a:prstDash val="solid"/>
+                      <a:round/>
+                      <a:headEnd type="none" w="med" len="med"/>
+                      <a:tailEnd type="none" w="med" len="med"/>
+                    </a:lnL>
+                    <a:lnR w="9525" cap="flat" cmpd="sng" algn="ctr">
+                      <a:solidFill>
+                        <a:srgbClr val="DDE4F0"/>
+                      </a:solidFill>
+                      <a:prstDash val="solid"/>
+                      <a:round/>
+                      <a:headEnd type="none" w="med" len="med"/>
+                      <a:tailEnd type="none" w="med" len="med"/>
+                    </a:lnR>
+                    <a:lnT w="9525" cap="flat" cmpd="sng" algn="ctr">
+                      <a:solidFill>
+                        <a:srgbClr val="DDE4F0"/>
+                      </a:solidFill>
+                      <a:prstDash val="solid"/>
+                      <a:round/>
+                      <a:headEnd type="none" w="med" len="med"/>
+                      <a:tailEnd type="none" w="med" len="med"/>
+                    </a:lnT>
+                    <a:lnB w="9525" cap="flat" cmpd="sng" algn="ctr">
+                      <a:solidFill>
+                        <a:srgbClr val="DDE4F0"/>
+                      </a:solidFill>
+                      <a:prstDash val="solid"/>
+                      <a:round/>
+                      <a:headEnd type="none" w="med" len="med"/>
+                      <a:tailEnd type="none" w="med" len="med"/>
+                    </a:lnB>
+                  </a:tcPr>
+                </a:tc>
+                <a:tc>
+                  <a:txBody>
+                    <a:bodyPr/>
+                    <a:lstStyle/>
+                    <a:p>
+                      <a:pPr indent="0" marL="0">
+                        <a:buNone/>
+                      </a:pPr>
+                      <a:r>
+                        <a:rPr lang="en-US" sz="1400" dirty="0">
+                          <a:solidFill>
+                            <a:schemeClr val="tx1"/>
+                          </a:solidFill>
+                        </a:rPr>
+                        <a:t>Customer Success Manager: looks after a set of customer accounts</a:t>
+                      </a:r>
+                      <a:endParaRPr lang="en-US" sz="1400" dirty="0"/>
+                    </a:p>
+                  </a:txBody>
+                  <a:tcPr marL="101600" marR="101600" marT="38100" marB="38100" anchor="ctr">
+                    <a:lnL w="9525" cap="flat" cmpd="sng" algn="ctr">
+                      <a:solidFill>
+                        <a:srgbClr val="DDE4F0"/>
+                      </a:solidFill>
+                      <a:prstDash val="solid"/>
+                      <a:round/>
+                      <a:headEnd type="none" w="med" len="med"/>
+                      <a:tailEnd type="none" w="med" len="med"/>
+                    </a:lnL>
+                    <a:lnR w="9525" cap="flat" cmpd="sng" algn="ctr">
+                      <a:solidFill>
+                        <a:srgbClr val="DDE4F0"/>
+                      </a:solidFill>
+                      <a:prstDash val="solid"/>
+                      <a:round/>
+                      <a:headEnd type="none" w="med" len="med"/>
+                      <a:tailEnd type="none" w="med" len="med"/>
+                    </a:lnR>
+                    <a:lnT w="9525" cap="flat" cmpd="sng" algn="ctr">
+                      <a:solidFill>
+                        <a:srgbClr val="DDE4F0"/>
+                      </a:solidFill>
+                      <a:prstDash val="solid"/>
+                      <a:round/>
+                      <a:headEnd type="none" w="med" len="med"/>
+                      <a:tailEnd type="none" w="med" len="med"/>
+                    </a:lnT>
+                    <a:lnB w="9525" cap="flat" cmpd="sng" algn="ctr">
+                      <a:solidFill>
+                        <a:srgbClr val="DDE4F0"/>
+                      </a:solidFill>
+                      <a:prstDash val="solid"/>
+                      <a:round/>
+                      <a:headEnd type="none" w="med" len="med"/>
+                      <a:tailEnd type="none" w="med" len="med"/>
+                    </a:lnB>
+                  </a:tcPr>
+                </a:tc>
+              </a:tr>
+              <a:tr h="713232">
+                <a:tc>
+                  <a:txBody>
+                    <a:bodyPr/>
+                    <a:lstStyle/>
+                    <a:p>
+                      <a:pPr indent="0" marL="0">
+                        <a:buNone/>
+                      </a:pPr>
+                      <a:r>
+                        <a:rPr lang="en-US" sz="1400" b="1" dirty="0">
+                          <a:solidFill>
+                            <a:schemeClr val="tx2"/>
+                          </a:solidFill>
+                        </a:rPr>
+                        <a:t>ARR</a:t>
+                      </a:r>
+                      <a:endParaRPr lang="en-US" sz="1400" dirty="0"/>
+                    </a:p>
+                  </a:txBody>
+                  <a:tcPr marL="101600" marR="101600" marT="38100" marB="38100" anchor="ctr">
+                    <a:lnL w="9525" cap="flat" cmpd="sng" algn="ctr">
+                      <a:solidFill>
+                        <a:srgbClr val="DDE4F0"/>
+                      </a:solidFill>
+                      <a:prstDash val="solid"/>
+                      <a:round/>
+                      <a:headEnd type="none" w="med" len="med"/>
+                      <a:tailEnd type="none" w="med" len="med"/>
+                    </a:lnL>
+                    <a:lnR w="9525" cap="flat" cmpd="sng" algn="ctr">
+                      <a:solidFill>
+                        <a:srgbClr val="DDE4F0"/>
+                      </a:solidFill>
+                      <a:prstDash val="solid"/>
+                      <a:round/>
+                      <a:headEnd type="none" w="med" len="med"/>
+                      <a:tailEnd type="none" w="med" len="med"/>
+                    </a:lnR>
+                    <a:lnT w="9525" cap="flat" cmpd="sng" algn="ctr">
+                      <a:solidFill>
+                        <a:srgbClr val="DDE4F0"/>
+                      </a:solidFill>
+                      <a:prstDash val="solid"/>
+                      <a:round/>
+                      <a:headEnd type="none" w="med" len="med"/>
+                      <a:tailEnd type="none" w="med" len="med"/>
+                    </a:lnT>
+                    <a:lnB w="9525" cap="flat" cmpd="sng" algn="ctr">
+                      <a:solidFill>
+                        <a:srgbClr val="DDE4F0"/>
+                      </a:solidFill>
+                      <a:prstDash val="solid"/>
+                      <a:round/>
+                      <a:headEnd type="none" w="med" len="med"/>
+                      <a:tailEnd type="none" w="med" len="med"/>
+                    </a:lnB>
+                  </a:tcPr>
+                </a:tc>
+                <a:tc>
+                  <a:txBody>
+                    <a:bodyPr/>
+                    <a:lstStyle/>
+                    <a:p>
+                      <a:pPr indent="0" marL="0">
+                        <a:buNone/>
+                      </a:pPr>
+                      <a:r>
+                        <a:rPr lang="en-US" sz="1400" dirty="0">
+                          <a:solidFill>
+                            <a:schemeClr val="tx1"/>
+                          </a:solidFill>
+                        </a:rPr>
+                        <a:t>Annual recurring revenue: what a customer pays per year</a:t>
+                      </a:r>
+                      <a:endParaRPr lang="en-US" sz="1400" dirty="0"/>
+                    </a:p>
+                  </a:txBody>
+                  <a:tcPr marL="101600" marR="101600" marT="38100" marB="38100" anchor="ctr">
+                    <a:lnL w="9525" cap="flat" cmpd="sng" algn="ctr">
+                      <a:solidFill>
+                        <a:srgbClr val="DDE4F0"/>
+                      </a:solidFill>
+                      <a:prstDash val="solid"/>
+                      <a:round/>
+                      <a:headEnd type="none" w="med" len="med"/>
+                      <a:tailEnd type="none" w="med" len="med"/>
+                    </a:lnL>
+                    <a:lnR w="9525" cap="flat" cmpd="sng" algn="ctr">
+                      <a:solidFill>
+                        <a:srgbClr val="DDE4F0"/>
+                      </a:solidFill>
+                      <a:prstDash val="solid"/>
+                      <a:round/>
+                      <a:headEnd type="none" w="med" len="med"/>
+                      <a:tailEnd type="none" w="med" len="med"/>
+                    </a:lnR>
+                    <a:lnT w="9525" cap="flat" cmpd="sng" algn="ctr">
+                      <a:solidFill>
+                        <a:srgbClr val="DDE4F0"/>
+                      </a:solidFill>
+                      <a:prstDash val="solid"/>
+                      <a:round/>
+                      <a:headEnd type="none" w="med" len="med"/>
+                      <a:tailEnd type="none" w="med" len="med"/>
+                    </a:lnT>
+                    <a:lnB w="9525" cap="flat" cmpd="sng" algn="ctr">
+                      <a:solidFill>
+                        <a:srgbClr val="DDE4F0"/>
+                      </a:solidFill>
+                      <a:prstDash val="solid"/>
+                      <a:round/>
+                      <a:headEnd type="none" w="med" len="med"/>
+                      <a:tailEnd type="none" w="med" len="med"/>
+                    </a:lnB>
+                  </a:tcPr>
+                </a:tc>
+              </a:tr>
+              <a:tr h="713232">
+                <a:tc>
+                  <a:txBody>
+                    <a:bodyPr/>
+                    <a:lstStyle/>
+                    <a:p>
+                      <a:pPr indent="0" marL="0">
+                        <a:buNone/>
+                      </a:pPr>
+                      <a:r>
+                        <a:rPr lang="en-US" sz="1400" b="1" dirty="0">
+                          <a:solidFill>
+                            <a:schemeClr val="tx2"/>
+                          </a:solidFill>
+                        </a:rPr>
+                        <a:t>Churn</a:t>
+                      </a:r>
+                      <a:endParaRPr lang="en-US" sz="1400" dirty="0"/>
+                    </a:p>
+                  </a:txBody>
+                  <a:tcPr marL="101600" marR="101600" marT="38100" marB="38100" anchor="ctr">
+                    <a:lnL w="9525" cap="flat" cmpd="sng" algn="ctr">
+                      <a:solidFill>
+                        <a:srgbClr val="DDE4F0"/>
+                      </a:solidFill>
+                      <a:prstDash val="solid"/>
+                      <a:round/>
+                      <a:headEnd type="none" w="med" len="med"/>
+                      <a:tailEnd type="none" w="med" len="med"/>
+                    </a:lnL>
+                    <a:lnR w="9525" cap="flat" cmpd="sng" algn="ctr">
+                      <a:solidFill>
+                        <a:srgbClr val="DDE4F0"/>
+                      </a:solidFill>
+                      <a:prstDash val="solid"/>
+                      <a:round/>
+                      <a:headEnd type="none" w="med" len="med"/>
+                      <a:tailEnd type="none" w="med" len="med"/>
+                    </a:lnR>
+                    <a:lnT w="9525" cap="flat" cmpd="sng" algn="ctr">
+                      <a:solidFill>
+                        <a:srgbClr val="DDE4F0"/>
+                      </a:solidFill>
+                      <a:prstDash val="solid"/>
+                      <a:round/>
+                      <a:headEnd type="none" w="med" len="med"/>
+                      <a:tailEnd type="none" w="med" len="med"/>
+                    </a:lnT>
+                    <a:lnB w="9525" cap="flat" cmpd="sng" algn="ctr">
+                      <a:solidFill>
+                        <a:srgbClr val="DDE4F0"/>
+                      </a:solidFill>
+                      <a:prstDash val="solid"/>
+                      <a:round/>
+                      <a:headEnd type="none" w="med" len="med"/>
+                      <a:tailEnd type="none" w="med" len="med"/>
+                    </a:lnB>
+                  </a:tcPr>
+                </a:tc>
+                <a:tc>
+                  <a:txBody>
+                    <a:bodyPr/>
+                    <a:lstStyle/>
+                    <a:p>
+                      <a:pPr indent="0" marL="0">
+                        <a:buNone/>
+                      </a:pPr>
+                      <a:r>
+                        <a:rPr lang="en-US" sz="1400" dirty="0">
+                          <a:solidFill>
+                            <a:schemeClr val="tx1"/>
+                          </a:solidFill>
+                        </a:rPr>
+                        <a:t>A customer not renewing</a:t>
+                      </a:r>
+                      <a:endParaRPr lang="en-US" sz="1400" dirty="0"/>
+                    </a:p>
+                  </a:txBody>
+                  <a:tcPr marL="101600" marR="101600" marT="38100" marB="38100" anchor="ctr">
+                    <a:lnL w="9525" cap="flat" cmpd="sng" algn="ctr">
+                      <a:solidFill>
+                        <a:srgbClr val="DDE4F0"/>
+                      </a:solidFill>
+                      <a:prstDash val="solid"/>
+                      <a:round/>
+                      <a:headEnd type="none" w="med" len="med"/>
+                      <a:tailEnd type="none" w="med" len="med"/>
+                    </a:lnL>
+                    <a:lnR w="9525" cap="flat" cmpd="sng" algn="ctr">
+                      <a:solidFill>
+                        <a:srgbClr val="DDE4F0"/>
+                      </a:solidFill>
+                      <a:prstDash val="solid"/>
+                      <a:round/>
+                      <a:headEnd type="none" w="med" len="med"/>
+                      <a:tailEnd type="none" w="med" len="med"/>
+                    </a:lnR>
+                    <a:lnT w="9525" cap="flat" cmpd="sng" algn="ctr">
+                      <a:solidFill>
+                        <a:srgbClr val="DDE4F0"/>
+                      </a:solidFill>
+                      <a:prstDash val="solid"/>
+                      <a:round/>
+                      <a:headEnd type="none" w="med" len="med"/>
+                      <a:tailEnd type="none" w="med" len="med"/>
+                    </a:lnT>
+                    <a:lnB w="9525" cap="flat" cmpd="sng" algn="ctr">
+                      <a:solidFill>
+                        <a:srgbClr val="DDE4F0"/>
+                      </a:solidFill>
+                      <a:prstDash val="solid"/>
+                      <a:round/>
+                      <a:headEnd type="none" w="med" len="med"/>
+                      <a:tailEnd type="none" w="med" len="med"/>
+                    </a:lnB>
+                  </a:tcPr>
+                </a:tc>
+              </a:tr>
+              <a:tr h="713232">
+                <a:tc>
+                  <a:txBody>
+                    <a:bodyPr/>
+                    <a:lstStyle/>
+                    <a:p>
+                      <a:pPr indent="0" marL="0">
+                        <a:buNone/>
+                      </a:pPr>
+                      <a:r>
+                        <a:rPr lang="en-US" sz="1400" b="1" dirty="0">
+                          <a:solidFill>
+                            <a:schemeClr val="tx2"/>
+                          </a:solidFill>
+                        </a:rPr>
+                        <a:t>CRM</a:t>
+                      </a:r>
+                      <a:endParaRPr lang="en-US" sz="1400" dirty="0"/>
+                    </a:p>
+                  </a:txBody>
+                  <a:tcPr marL="101600" marR="101600" marT="38100" marB="38100" anchor="ctr">
+                    <a:lnL w="9525" cap="flat" cmpd="sng" algn="ctr">
+                      <a:solidFill>
+                        <a:srgbClr val="DDE4F0"/>
+                      </a:solidFill>
+                      <a:prstDash val="solid"/>
+                      <a:round/>
+                      <a:headEnd type="none" w="med" len="med"/>
+                      <a:tailEnd type="none" w="med" len="med"/>
+                    </a:lnL>
+                    <a:lnR w="9525" cap="flat" cmpd="sng" algn="ctr">
+                      <a:solidFill>
+                        <a:srgbClr val="DDE4F0"/>
+                      </a:solidFill>
+                      <a:prstDash val="solid"/>
+                      <a:round/>
+                      <a:headEnd type="none" w="med" len="med"/>
+                      <a:tailEnd type="none" w="med" len="med"/>
+                    </a:lnR>
+                    <a:lnT w="9525" cap="flat" cmpd="sng" algn="ctr">
+                      <a:solidFill>
+                        <a:srgbClr val="DDE4F0"/>
+                      </a:solidFill>
+                      <a:prstDash val="solid"/>
+                      <a:round/>
+                      <a:headEnd type="none" w="med" len="med"/>
+                      <a:tailEnd type="none" w="med" len="med"/>
+                    </a:lnT>
+                    <a:lnB w="9525" cap="flat" cmpd="sng" algn="ctr">
+                      <a:solidFill>
+                        <a:srgbClr val="DDE4F0"/>
+                      </a:solidFill>
+                      <a:prstDash val="solid"/>
+                      <a:round/>
+                      <a:headEnd type="none" w="med" len="med"/>
+                      <a:tailEnd type="none" w="med" len="med"/>
+                    </a:lnB>
+                  </a:tcPr>
+                </a:tc>
+                <a:tc>
+                  <a:txBody>
+                    <a:bodyPr/>
+                    <a:lstStyle/>
+                    <a:p>
+                      <a:pPr indent="0" marL="0">
+                        <a:buNone/>
+                      </a:pPr>
+                      <a:r>
+                        <a:rPr lang="en-US" sz="1400" dirty="0">
+                          <a:solidFill>
+                            <a:schemeClr val="tx1"/>
+                          </a:solidFill>
+                        </a:rPr>
+                        <a:t>The sales system (e.g. Salesforce) where accounts and renewals live</a:t>
+                      </a:r>
+                      <a:endParaRPr lang="en-US" sz="1400" dirty="0"/>
+                    </a:p>
+                  </a:txBody>
+                  <a:tcPr marL="101600" marR="101600" marT="38100" marB="38100" anchor="ctr">
+                    <a:lnL w="9525" cap="flat" cmpd="sng" algn="ctr">
+                      <a:solidFill>
+                        <a:srgbClr val="DDE4F0"/>
+                      </a:solidFill>
+                      <a:prstDash val="solid"/>
+                      <a:round/>
+                      <a:headEnd type="none" w="med" len="med"/>
+                      <a:tailEnd type="none" w="med" len="med"/>
+                    </a:lnL>
+                    <a:lnR w="9525" cap="flat" cmpd="sng" algn="ctr">
+                      <a:solidFill>
+                        <a:srgbClr val="DDE4F0"/>
+                      </a:solidFill>
+                      <a:prstDash val="solid"/>
+                      <a:round/>
+                      <a:headEnd type="none" w="med" len="med"/>
+                      <a:tailEnd type="none" w="med" len="med"/>
+                    </a:lnR>
+                    <a:lnT w="9525" cap="flat" cmpd="sng" algn="ctr">
+                      <a:solidFill>
+                        <a:srgbClr val="DDE4F0"/>
+                      </a:solidFill>
+                      <a:prstDash val="solid"/>
+                      <a:round/>
+                      <a:headEnd type="none" w="med" len="med"/>
+                      <a:tailEnd type="none" w="med" len="med"/>
+                    </a:lnT>
+                    <a:lnB w="9525" cap="flat" cmpd="sng" algn="ctr">
+                      <a:solidFill>
+                        <a:srgbClr val="DDE4F0"/>
+                      </a:solidFill>
+                      <a:prstDash val="solid"/>
+                      <a:round/>
+                      <a:headEnd type="none" w="med" len="med"/>
+                      <a:tailEnd type="none" w="med" len="med"/>
+                    </a:lnB>
+                  </a:tcPr>
+                </a:tc>
+              </a:tr>
+              <a:tr h="713232">
+                <a:tc>
+                  <a:txBody>
+                    <a:bodyPr/>
+                    <a:lstStyle/>
+                    <a:p>
+                      <a:pPr indent="0" marL="0">
+                        <a:buNone/>
+                      </a:pPr>
+                      <a:r>
+                        <a:rPr lang="en-US" sz="1400" b="1" dirty="0">
+                          <a:solidFill>
+                            <a:schemeClr val="tx2"/>
+                          </a:solidFill>
+                        </a:rPr>
+                        <a:t>CSAT</a:t>
+                      </a:r>
+                      <a:endParaRPr lang="en-US" sz="1400" dirty="0"/>
+                    </a:p>
+                  </a:txBody>
+                  <a:tcPr marL="101600" marR="101600" marT="38100" marB="38100" anchor="ctr">
+                    <a:lnL w="9525" cap="flat" cmpd="sng" algn="ctr">
+                      <a:solidFill>
+                        <a:srgbClr val="DDE4F0"/>
+                      </a:solidFill>
+                      <a:prstDash val="solid"/>
+                      <a:round/>
+                      <a:headEnd type="none" w="med" len="med"/>
+                      <a:tailEnd type="none" w="med" len="med"/>
+                    </a:lnL>
+                    <a:lnR w="9525" cap="flat" cmpd="sng" algn="ctr">
+                      <a:solidFill>
+                        <a:srgbClr val="DDE4F0"/>
+                      </a:solidFill>
+                      <a:prstDash val="solid"/>
+                      <a:round/>
+                      <a:headEnd type="none" w="med" len="med"/>
+                      <a:tailEnd type="none" w="med" len="med"/>
+                    </a:lnR>
+                    <a:lnT w="9525" cap="flat" cmpd="sng" algn="ctr">
+                      <a:solidFill>
+                        <a:srgbClr val="DDE4F0"/>
+                      </a:solidFill>
+                      <a:prstDash val="solid"/>
+                      <a:round/>
+                      <a:headEnd type="none" w="med" len="med"/>
+                      <a:tailEnd type="none" w="med" len="med"/>
+                    </a:lnT>
+                    <a:lnB w="9525" cap="flat" cmpd="sng" algn="ctr">
+                      <a:solidFill>
+                        <a:srgbClr val="DDE4F0"/>
+                      </a:solidFill>
+                      <a:prstDash val="solid"/>
+                      <a:round/>
+                      <a:headEnd type="none" w="med" len="med"/>
+                      <a:tailEnd type="none" w="med" len="med"/>
+                    </a:lnB>
+                  </a:tcPr>
+                </a:tc>
+                <a:tc>
+                  <a:txBody>
+                    <a:bodyPr/>
+                    <a:lstStyle/>
+                    <a:p>
+                      <a:pPr indent="0" marL="0">
+                        <a:buNone/>
+                      </a:pPr>
+                      <a:r>
+                        <a:rPr lang="en-US" sz="1400" dirty="0">
+                          <a:solidFill>
+                            <a:schemeClr val="tx1"/>
+                          </a:solidFill>
+                        </a:rPr>
+                        <a:t>The customer's good/bad rating on a support ticket</a:t>
+                      </a:r>
+                      <a:endParaRPr lang="en-US" sz="1400" dirty="0"/>
+                    </a:p>
+                  </a:txBody>
+                  <a:tcPr marL="101600" marR="101600" marT="38100" marB="38100" anchor="ctr">
+                    <a:lnL w="9525" cap="flat" cmpd="sng" algn="ctr">
+                      <a:solidFill>
+                        <a:srgbClr val="DDE4F0"/>
+                      </a:solidFill>
+                      <a:prstDash val="solid"/>
+                      <a:round/>
+                      <a:headEnd type="none" w="med" len="med"/>
+                      <a:tailEnd type="none" w="med" len="med"/>
+                    </a:lnL>
+                    <a:lnR w="9525" cap="flat" cmpd="sng" algn="ctr">
+                      <a:solidFill>
+                        <a:srgbClr val="DDE4F0"/>
+                      </a:solidFill>
+                      <a:prstDash val="solid"/>
+                      <a:round/>
+                      <a:headEnd type="none" w="med" len="med"/>
+                      <a:tailEnd type="none" w="med" len="med"/>
+                    </a:lnR>
+                    <a:lnT w="9525" cap="flat" cmpd="sng" algn="ctr">
+                      <a:solidFill>
+                        <a:srgbClr val="DDE4F0"/>
+                      </a:solidFill>
+                      <a:prstDash val="solid"/>
+                      <a:round/>
+                      <a:headEnd type="none" w="med" len="med"/>
+                      <a:tailEnd type="none" w="med" len="med"/>
+                    </a:lnT>
+                    <a:lnB w="9525" cap="flat" cmpd="sng" algn="ctr">
+                      <a:solidFill>
+                        <a:srgbClr val="DDE4F0"/>
+                      </a:solidFill>
+                      <a:prstDash val="solid"/>
+                      <a:round/>
+                      <a:headEnd type="none" w="med" len="med"/>
+                      <a:tailEnd type="none" w="med" len="med"/>
+                    </a:lnB>
+                  </a:tcPr>
+                </a:tc>
+              </a:tr>
+              <a:tr h="713232">
+                <a:tc>
+                  <a:txBody>
+                    <a:bodyPr/>
+                    <a:lstStyle/>
+                    <a:p>
+                      <a:pPr indent="0" marL="0">
+                        <a:buNone/>
+                      </a:pPr>
+                      <a:r>
+                        <a:rPr lang="en-US" sz="1400" b="1" dirty="0">
+                          <a:solidFill>
+                            <a:schemeClr val="tx2"/>
+                          </a:solidFill>
+                        </a:rPr>
+                        <a:t>Tenant</a:t>
+                      </a:r>
+                      <a:endParaRPr lang="en-US" sz="1400" dirty="0"/>
+                    </a:p>
+                  </a:txBody>
+                  <a:tcPr marL="101600" marR="101600" marT="38100" marB="38100" anchor="ctr">
+                    <a:lnL w="9525" cap="flat" cmpd="sng" algn="ctr">
+                      <a:solidFill>
+                        <a:srgbClr val="DDE4F0"/>
+                      </a:solidFill>
+                      <a:prstDash val="solid"/>
+                      <a:round/>
+                      <a:headEnd type="none" w="med" len="med"/>
+                      <a:tailEnd type="none" w="med" len="med"/>
+                    </a:lnL>
+                    <a:lnR w="9525" cap="flat" cmpd="sng" algn="ctr">
+                      <a:solidFill>
+                        <a:srgbClr val="DDE4F0"/>
+                      </a:solidFill>
+                      <a:prstDash val="solid"/>
+                      <a:round/>
+                      <a:headEnd type="none" w="med" len="med"/>
+                      <a:tailEnd type="none" w="med" len="med"/>
+                    </a:lnR>
+                    <a:lnT w="9525" cap="flat" cmpd="sng" algn="ctr">
+                      <a:solidFill>
+                        <a:srgbClr val="DDE4F0"/>
+                      </a:solidFill>
+                      <a:prstDash val="solid"/>
+                      <a:round/>
+                      <a:headEnd type="none" w="med" len="med"/>
+                      <a:tailEnd type="none" w="med" len="med"/>
+                    </a:lnT>
+                    <a:lnB w="9525" cap="flat" cmpd="sng" algn="ctr">
+                      <a:solidFill>
+                        <a:srgbClr val="DDE4F0"/>
+                      </a:solidFill>
+                      <a:prstDash val="solid"/>
+                      <a:round/>
+                      <a:headEnd type="none" w="med" len="med"/>
+                      <a:tailEnd type="none" w="med" len="med"/>
+                    </a:lnB>
+                  </a:tcPr>
+                </a:tc>
+                <a:tc>
+                  <a:txBody>
+                    <a:bodyPr/>
+                    <a:lstStyle/>
+                    <a:p>
+                      <a:pPr indent="0" marL="0">
+                        <a:buNone/>
+                      </a:pPr>
+                      <a:r>
+                        <a:rPr lang="en-US" sz="1400" dirty="0">
+                          <a:solidFill>
+                            <a:schemeClr val="tx1"/>
+                          </a:solidFill>
+                        </a:rPr>
+                        <a:t>One customer organisation using Triage (Northwind, Helios, Quill)</a:t>
+                      </a:r>
+                      <a:endParaRPr lang="en-US" sz="1400" dirty="0"/>
+                    </a:p>
+                  </a:txBody>
+                  <a:tcPr marL="101600" marR="101600" marT="38100" marB="38100" anchor="ctr">
+                    <a:lnL w="9525" cap="flat" cmpd="sng" algn="ctr">
+                      <a:solidFill>
+                        <a:srgbClr val="DDE4F0"/>
+                      </a:solidFill>
+                      <a:prstDash val="solid"/>
+                      <a:round/>
+                      <a:headEnd type="none" w="med" len="med"/>
+                      <a:tailEnd type="none" w="med" len="med"/>
+                    </a:lnL>
+                    <a:lnR w="9525" cap="flat" cmpd="sng" algn="ctr">
+                      <a:solidFill>
+                        <a:srgbClr val="DDE4F0"/>
+                      </a:solidFill>
+                      <a:prstDash val="solid"/>
+                      <a:round/>
+                      <a:headEnd type="none" w="med" len="med"/>
+                      <a:tailEnd type="none" w="med" len="med"/>
+                    </a:lnR>
+                    <a:lnT w="9525" cap="flat" cmpd="sng" algn="ctr">
+                      <a:solidFill>
+                        <a:srgbClr val="DDE4F0"/>
+                      </a:solidFill>
+                      <a:prstDash val="solid"/>
+                      <a:round/>
+                      <a:headEnd type="none" w="med" len="med"/>
+                      <a:tailEnd type="none" w="med" len="med"/>
+                    </a:lnT>
+                    <a:lnB w="9525" cap="flat" cmpd="sng" algn="ctr">
+                      <a:solidFill>
+                        <a:srgbClr val="DDE4F0"/>
+                      </a:solidFill>
+                      <a:prstDash val="solid"/>
+                      <a:round/>
+                      <a:headEnd type="none" w="med" len="med"/>
+                      <a:tailEnd type="none" w="med" len="med"/>
+                    </a:lnB>
+                  </a:tcPr>
+                </a:tc>
+              </a:tr>
+            </a:tbl>
+          </a:graphicData>
+        </a:graphic>
+      </p:graphicFrame>
+      <p:graphicFrame>
+        <p:nvGraphicFramePr>
+          <p:cNvPr id="33" name="table-297"/>
+          <p:cNvGraphicFramePr>
+            <a:graphicFrameLocks noGrp="1"/>
+          </p:cNvGraphicFramePr>
+          <p:nvPr>
+            <p:extLst>
+              <p:ext uri="{D42A27DB-BD31-4B8C-83A1-F6EECF244321}">
+                <p14:modId xmlns:p14="http://schemas.microsoft.com/office/powerpoint/2010/main" val="1579011935"/>
+              </p:ext>
+            </p:extLst>
+          </p:nvPr>
+        </p:nvGraphicFramePr>
+        <p:xfrm>
+          <a:off x="6233008" y="1600200"/>
+          <a:ext cx="5410048" cy="914400"/>
+        </p:xfrm>
+        <a:graphic>
+          <a:graphicData uri="http://schemas.openxmlformats.org/drawingml/2006/table">
+            <a:tbl>
+              <a:tblPr/>
+              <a:tblGrid>
+                <a:gridCol w="1783080"/>
+                <a:gridCol w="3626968"/>
+              </a:tblGrid>
+              <a:tr h="713232">
+                <a:tc>
+                  <a:txBody>
+                    <a:bodyPr/>
+                    <a:lstStyle/>
+                    <a:p>
+                      <a:pPr indent="0" marL="0">
+                        <a:buNone/>
+                      </a:pPr>
+                      <a:r>
+                        <a:rPr lang="en-US" sz="1400" b="1" dirty="0">
+                          <a:solidFill>
+                            <a:schemeClr val="tx2"/>
+                          </a:solidFill>
+                        </a:rPr>
+                        <a:t>LLM</a:t>
+                      </a:r>
+                      <a:endParaRPr lang="en-US" sz="1400" dirty="0"/>
+                    </a:p>
+                  </a:txBody>
+                  <a:tcPr marL="101600" marR="101600" marT="38100" marB="38100" anchor="ctr">
+                    <a:lnL w="9525" cap="flat" cmpd="sng" algn="ctr">
+                      <a:solidFill>
+                        <a:srgbClr val="DDE4F0"/>
+                      </a:solidFill>
+                      <a:prstDash val="solid"/>
+                      <a:round/>
+                      <a:headEnd type="none" w="med" len="med"/>
+                      <a:tailEnd type="none" w="med" len="med"/>
+                    </a:lnL>
+                    <a:lnR w="9525" cap="flat" cmpd="sng" algn="ctr">
+                      <a:solidFill>
+                        <a:srgbClr val="DDE4F0"/>
+                      </a:solidFill>
+                      <a:prstDash val="solid"/>
+                      <a:round/>
+                      <a:headEnd type="none" w="med" len="med"/>
+                      <a:tailEnd type="none" w="med" len="med"/>
+                    </a:lnR>
+                    <a:lnT w="9525" cap="flat" cmpd="sng" algn="ctr">
+                      <a:solidFill>
+                        <a:srgbClr val="DDE4F0"/>
+                      </a:solidFill>
+                      <a:prstDash val="solid"/>
+                      <a:round/>
+                      <a:headEnd type="none" w="med" len="med"/>
+                      <a:tailEnd type="none" w="med" len="med"/>
+                    </a:lnT>
+                    <a:lnB w="9525" cap="flat" cmpd="sng" algn="ctr">
+                      <a:solidFill>
+                        <a:srgbClr val="DDE4F0"/>
+                      </a:solidFill>
+                      <a:prstDash val="solid"/>
+                      <a:round/>
+                      <a:headEnd type="none" w="med" len="med"/>
+                      <a:tailEnd type="none" w="med" len="med"/>
+                    </a:lnB>
+                  </a:tcPr>
+                </a:tc>
+                <a:tc>
+                  <a:txBody>
+                    <a:bodyPr/>
+                    <a:lstStyle/>
+                    <a:p>
+                      <a:pPr indent="0" marL="0">
+                        <a:buNone/>
+                      </a:pPr>
+                      <a:r>
+                        <a:rPr lang="en-US" sz="1400" dirty="0">
+                          <a:solidFill>
+                            <a:schemeClr val="tx1"/>
+                          </a:solidFill>
+                        </a:rPr>
+                        <a:t>Large language model (e.g. GPT): writes the notes, never ranks</a:t>
+                      </a:r>
+                      <a:endParaRPr lang="en-US" sz="1400" dirty="0"/>
+                    </a:p>
+                  </a:txBody>
+                  <a:tcPr marL="101600" marR="101600" marT="38100" marB="38100" anchor="ctr">
+                    <a:lnL w="9525" cap="flat" cmpd="sng" algn="ctr">
+                      <a:solidFill>
+                        <a:srgbClr val="DDE4F0"/>
+                      </a:solidFill>
+                      <a:prstDash val="solid"/>
+                      <a:round/>
+                      <a:headEnd type="none" w="med" len="med"/>
+                      <a:tailEnd type="none" w="med" len="med"/>
+                    </a:lnL>
+                    <a:lnR w="9525" cap="flat" cmpd="sng" algn="ctr">
+                      <a:solidFill>
+                        <a:srgbClr val="DDE4F0"/>
+                      </a:solidFill>
+                      <a:prstDash val="solid"/>
+                      <a:round/>
+                      <a:headEnd type="none" w="med" len="med"/>
+                      <a:tailEnd type="none" w="med" len="med"/>
+                    </a:lnR>
+                    <a:lnT w="9525" cap="flat" cmpd="sng" algn="ctr">
+                      <a:solidFill>
+                        <a:srgbClr val="DDE4F0"/>
+                      </a:solidFill>
+                      <a:prstDash val="solid"/>
+                      <a:round/>
+                      <a:headEnd type="none" w="med" len="med"/>
+                      <a:tailEnd type="none" w="med" len="med"/>
+                    </a:lnT>
+                    <a:lnB w="9525" cap="flat" cmpd="sng" algn="ctr">
+                      <a:solidFill>
+                        <a:srgbClr val="DDE4F0"/>
+                      </a:solidFill>
+                      <a:prstDash val="solid"/>
+                      <a:round/>
+                      <a:headEnd type="none" w="med" len="med"/>
+                      <a:tailEnd type="none" w="med" len="med"/>
+                    </a:lnB>
+                  </a:tcPr>
+                </a:tc>
+              </a:tr>
+              <a:tr h="713232">
+                <a:tc>
+                  <a:txBody>
+                    <a:bodyPr/>
+                    <a:lstStyle/>
+                    <a:p>
+                      <a:pPr indent="0" marL="0">
+                        <a:buNone/>
+                      </a:pPr>
+                      <a:r>
+                        <a:rPr lang="en-US" sz="1400" b="1" dirty="0">
+                          <a:solidFill>
+                            <a:schemeClr val="tx2"/>
+                          </a:solidFill>
+                        </a:rPr>
+                        <a:t>Ranking accuracy</a:t>
+                      </a:r>
+                      <a:endParaRPr lang="en-US" sz="1400" dirty="0"/>
+                    </a:p>
+                  </a:txBody>
+                  <a:tcPr marL="101600" marR="101600" marT="38100" marB="38100" anchor="ctr">
+                    <a:lnL w="9525" cap="flat" cmpd="sng" algn="ctr">
+                      <a:solidFill>
+                        <a:srgbClr val="DDE4F0"/>
+                      </a:solidFill>
+                      <a:prstDash val="solid"/>
+                      <a:round/>
+                      <a:headEnd type="none" w="med" len="med"/>
+                      <a:tailEnd type="none" w="med" len="med"/>
+                    </a:lnL>
+                    <a:lnR w="9525" cap="flat" cmpd="sng" algn="ctr">
+                      <a:solidFill>
+                        <a:srgbClr val="DDE4F0"/>
+                      </a:solidFill>
+                      <a:prstDash val="solid"/>
+                      <a:round/>
+                      <a:headEnd type="none" w="med" len="med"/>
+                      <a:tailEnd type="none" w="med" len="med"/>
+                    </a:lnR>
+                    <a:lnT w="9525" cap="flat" cmpd="sng" algn="ctr">
+                      <a:solidFill>
+                        <a:srgbClr val="DDE4F0"/>
+                      </a:solidFill>
+                      <a:prstDash val="solid"/>
+                      <a:round/>
+                      <a:headEnd type="none" w="med" len="med"/>
+                      <a:tailEnd type="none" w="med" len="med"/>
+                    </a:lnT>
+                    <a:lnB w="9525" cap="flat" cmpd="sng" algn="ctr">
+                      <a:solidFill>
+                        <a:srgbClr val="DDE4F0"/>
+                      </a:solidFill>
+                      <a:prstDash val="solid"/>
+                      <a:round/>
+                      <a:headEnd type="none" w="med" len="med"/>
+                      <a:tailEnd type="none" w="med" len="med"/>
+                    </a:lnB>
+                  </a:tcPr>
+                </a:tc>
+                <a:tc>
+                  <a:txBody>
+                    <a:bodyPr/>
+                    <a:lstStyle/>
+                    <a:p>
+                      <a:pPr indent="0" marL="0">
+                        <a:buNone/>
+                      </a:pPr>
+                      <a:r>
+                        <a:rPr lang="en-US" sz="1400" dirty="0">
+                          <a:solidFill>
+                            <a:schemeClr val="tx1"/>
+                          </a:solidFill>
+                        </a:rPr>
+                        <a:t>How often a churner is ranked above a renewer (ROC AUC); 0.5 = coin flip</a:t>
+                      </a:r>
+                      <a:endParaRPr lang="en-US" sz="1400" dirty="0"/>
+                    </a:p>
+                  </a:txBody>
+                  <a:tcPr marL="101600" marR="101600" marT="38100" marB="38100" anchor="ctr">
+                    <a:lnL w="9525" cap="flat" cmpd="sng" algn="ctr">
+                      <a:solidFill>
+                        <a:srgbClr val="DDE4F0"/>
+                      </a:solidFill>
+                      <a:prstDash val="solid"/>
+                      <a:round/>
+                      <a:headEnd type="none" w="med" len="med"/>
+                      <a:tailEnd type="none" w="med" len="med"/>
+                    </a:lnL>
+                    <a:lnR w="9525" cap="flat" cmpd="sng" algn="ctr">
+                      <a:solidFill>
+                        <a:srgbClr val="DDE4F0"/>
+                      </a:solidFill>
+                      <a:prstDash val="solid"/>
+                      <a:round/>
+                      <a:headEnd type="none" w="med" len="med"/>
+                      <a:tailEnd type="none" w="med" len="med"/>
+                    </a:lnR>
+                    <a:lnT w="9525" cap="flat" cmpd="sng" algn="ctr">
+                      <a:solidFill>
+                        <a:srgbClr val="DDE4F0"/>
+                      </a:solidFill>
+                      <a:prstDash val="solid"/>
+                      <a:round/>
+                      <a:headEnd type="none" w="med" len="med"/>
+                      <a:tailEnd type="none" w="med" len="med"/>
+                    </a:lnT>
+                    <a:lnB w="9525" cap="flat" cmpd="sng" algn="ctr">
+                      <a:solidFill>
+                        <a:srgbClr val="DDE4F0"/>
+                      </a:solidFill>
+                      <a:prstDash val="solid"/>
+                      <a:round/>
+                      <a:headEnd type="none" w="med" len="med"/>
+                      <a:tailEnd type="none" w="med" len="med"/>
+                    </a:lnB>
+                  </a:tcPr>
+                </a:tc>
+              </a:tr>
+              <a:tr h="713232">
+                <a:tc>
+                  <a:txBody>
+                    <a:bodyPr/>
+                    <a:lstStyle/>
+                    <a:p>
+                      <a:pPr indent="0" marL="0">
+                        <a:buNone/>
+                      </a:pPr>
+                      <a:r>
+                        <a:rPr lang="en-US" sz="1400" b="1" dirty="0">
+                          <a:solidFill>
+                            <a:schemeClr val="tx2"/>
+                          </a:solidFill>
+                        </a:rPr>
+                        <a:t>Hit rate</a:t>
+                      </a:r>
+                      <a:endParaRPr lang="en-US" sz="1400" dirty="0"/>
+                    </a:p>
+                  </a:txBody>
+                  <a:tcPr marL="101600" marR="101600" marT="38100" marB="38100" anchor="ctr">
+                    <a:lnL w="9525" cap="flat" cmpd="sng" algn="ctr">
+                      <a:solidFill>
+                        <a:srgbClr val="DDE4F0"/>
+                      </a:solidFill>
+                      <a:prstDash val="solid"/>
+                      <a:round/>
+                      <a:headEnd type="none" w="med" len="med"/>
+                      <a:tailEnd type="none" w="med" len="med"/>
+                    </a:lnL>
+                    <a:lnR w="9525" cap="flat" cmpd="sng" algn="ctr">
+                      <a:solidFill>
+                        <a:srgbClr val="DDE4F0"/>
+                      </a:solidFill>
+                      <a:prstDash val="solid"/>
+                      <a:round/>
+                      <a:headEnd type="none" w="med" len="med"/>
+                      <a:tailEnd type="none" w="med" len="med"/>
+                    </a:lnR>
+                    <a:lnT w="9525" cap="flat" cmpd="sng" algn="ctr">
+                      <a:solidFill>
+                        <a:srgbClr val="DDE4F0"/>
+                      </a:solidFill>
+                      <a:prstDash val="solid"/>
+                      <a:round/>
+                      <a:headEnd type="none" w="med" len="med"/>
+                      <a:tailEnd type="none" w="med" len="med"/>
+                    </a:lnT>
+                    <a:lnB w="9525" cap="flat" cmpd="sng" algn="ctr">
+                      <a:solidFill>
+                        <a:srgbClr val="DDE4F0"/>
+                      </a:solidFill>
+                      <a:prstDash val="solid"/>
+                      <a:round/>
+                      <a:headEnd type="none" w="med" len="med"/>
+                      <a:tailEnd type="none" w="med" len="med"/>
+                    </a:lnB>
+                  </a:tcPr>
+                </a:tc>
+                <a:tc>
+                  <a:txBody>
+                    <a:bodyPr/>
+                    <a:lstStyle/>
+                    <a:p>
+                      <a:pPr indent="0" marL="0">
+                        <a:buNone/>
+                      </a:pPr>
+                      <a:r>
+                        <a:rPr lang="en-US" sz="1400" dirty="0">
+                          <a:solidFill>
+                            <a:schemeClr val="tx1"/>
+                          </a:solidFill>
+                        </a:rPr>
+                        <a:t>Share of call-list slots that were real churners (precision)</a:t>
+                      </a:r>
+                      <a:endParaRPr lang="en-US" sz="1400" dirty="0"/>
+                    </a:p>
+                  </a:txBody>
+                  <a:tcPr marL="101600" marR="101600" marT="38100" marB="38100" anchor="ctr">
+                    <a:lnL w="9525" cap="flat" cmpd="sng" algn="ctr">
+                      <a:solidFill>
+                        <a:srgbClr val="DDE4F0"/>
+                      </a:solidFill>
+                      <a:prstDash val="solid"/>
+                      <a:round/>
+                      <a:headEnd type="none" w="med" len="med"/>
+                      <a:tailEnd type="none" w="med" len="med"/>
+                    </a:lnL>
+                    <a:lnR w="9525" cap="flat" cmpd="sng" algn="ctr">
+                      <a:solidFill>
+                        <a:srgbClr val="DDE4F0"/>
+                      </a:solidFill>
+                      <a:prstDash val="solid"/>
+                      <a:round/>
+                      <a:headEnd type="none" w="med" len="med"/>
+                      <a:tailEnd type="none" w="med" len="med"/>
+                    </a:lnR>
+                    <a:lnT w="9525" cap="flat" cmpd="sng" algn="ctr">
+                      <a:solidFill>
+                        <a:srgbClr val="DDE4F0"/>
+                      </a:solidFill>
+                      <a:prstDash val="solid"/>
+                      <a:round/>
+                      <a:headEnd type="none" w="med" len="med"/>
+                      <a:tailEnd type="none" w="med" len="med"/>
+                    </a:lnT>
+                    <a:lnB w="9525" cap="flat" cmpd="sng" algn="ctr">
+                      <a:solidFill>
+                        <a:srgbClr val="DDE4F0"/>
+                      </a:solidFill>
+                      <a:prstDash val="solid"/>
+                      <a:round/>
+                      <a:headEnd type="none" w="med" len="med"/>
+                      <a:tailEnd type="none" w="med" len="med"/>
+                    </a:lnB>
+                  </a:tcPr>
+                </a:tc>
+              </a:tr>
+              <a:tr h="713232">
+                <a:tc>
+                  <a:txBody>
+                    <a:bodyPr/>
+                    <a:lstStyle/>
+                    <a:p>
+                      <a:pPr indent="0" marL="0">
+                        <a:buNone/>
+                      </a:pPr>
+                      <a:r>
+                        <a:rPr lang="en-US" sz="1400" b="1" dirty="0">
+                          <a:solidFill>
+                            <a:schemeClr val="tx2"/>
+                          </a:solidFill>
+                        </a:rPr>
+                        <a:t>Honest percentages</a:t>
+                      </a:r>
+                      <a:endParaRPr lang="en-US" sz="1400" dirty="0"/>
+                    </a:p>
+                  </a:txBody>
+                  <a:tcPr marL="101600" marR="101600" marT="38100" marB="38100" anchor="ctr">
+                    <a:lnL w="9525" cap="flat" cmpd="sng" algn="ctr">
+                      <a:solidFill>
+                        <a:srgbClr val="DDE4F0"/>
+                      </a:solidFill>
+                      <a:prstDash val="solid"/>
+                      <a:round/>
+                      <a:headEnd type="none" w="med" len="med"/>
+                      <a:tailEnd type="none" w="med" len="med"/>
+                    </a:lnL>
+                    <a:lnR w="9525" cap="flat" cmpd="sng" algn="ctr">
+                      <a:solidFill>
+                        <a:srgbClr val="DDE4F0"/>
+                      </a:solidFill>
+                      <a:prstDash val="solid"/>
+                      <a:round/>
+                      <a:headEnd type="none" w="med" len="med"/>
+                      <a:tailEnd type="none" w="med" len="med"/>
+                    </a:lnR>
+                    <a:lnT w="9525" cap="flat" cmpd="sng" algn="ctr">
+                      <a:solidFill>
+                        <a:srgbClr val="DDE4F0"/>
+                      </a:solidFill>
+                      <a:prstDash val="solid"/>
+                      <a:round/>
+                      <a:headEnd type="none" w="med" len="med"/>
+                      <a:tailEnd type="none" w="med" len="med"/>
+                    </a:lnT>
+                    <a:lnB w="9525" cap="flat" cmpd="sng" algn="ctr">
+                      <a:solidFill>
+                        <a:srgbClr val="DDE4F0"/>
+                      </a:solidFill>
+                      <a:prstDash val="solid"/>
+                      <a:round/>
+                      <a:headEnd type="none" w="med" len="med"/>
+                      <a:tailEnd type="none" w="med" len="med"/>
+                    </a:lnB>
+                  </a:tcPr>
+                </a:tc>
+                <a:tc>
+                  <a:txBody>
+                    <a:bodyPr/>
+                    <a:lstStyle/>
+                    <a:p>
+                      <a:pPr indent="0" marL="0">
+                        <a:buNone/>
+                      </a:pPr>
+                      <a:r>
+                        <a:rPr lang="en-US" sz="1400" dirty="0">
+                          <a:solidFill>
+                            <a:schemeClr val="tx1"/>
+                          </a:solidFill>
+                        </a:rPr>
+                        <a:t>"20%" really means about 1 in 5 (calibration)</a:t>
+                      </a:r>
+                      <a:endParaRPr lang="en-US" sz="1400" dirty="0"/>
+                    </a:p>
+                  </a:txBody>
+                  <a:tcPr marL="101600" marR="101600" marT="38100" marB="38100" anchor="ctr">
+                    <a:lnL w="9525" cap="flat" cmpd="sng" algn="ctr">
+                      <a:solidFill>
+                        <a:srgbClr val="DDE4F0"/>
+                      </a:solidFill>
+                      <a:prstDash val="solid"/>
+                      <a:round/>
+                      <a:headEnd type="none" w="med" len="med"/>
+                      <a:tailEnd type="none" w="med" len="med"/>
+                    </a:lnL>
+                    <a:lnR w="9525" cap="flat" cmpd="sng" algn="ctr">
+                      <a:solidFill>
+                        <a:srgbClr val="DDE4F0"/>
+                      </a:solidFill>
+                      <a:prstDash val="solid"/>
+                      <a:round/>
+                      <a:headEnd type="none" w="med" len="med"/>
+                      <a:tailEnd type="none" w="med" len="med"/>
+                    </a:lnR>
+                    <a:lnT w="9525" cap="flat" cmpd="sng" algn="ctr">
+                      <a:solidFill>
+                        <a:srgbClr val="DDE4F0"/>
+                      </a:solidFill>
+                      <a:prstDash val="solid"/>
+                      <a:round/>
+                      <a:headEnd type="none" w="med" len="med"/>
+                      <a:tailEnd type="none" w="med" len="med"/>
+                    </a:lnT>
+                    <a:lnB w="9525" cap="flat" cmpd="sng" algn="ctr">
+                      <a:solidFill>
+                        <a:srgbClr val="DDE4F0"/>
+                      </a:solidFill>
+                      <a:prstDash val="solid"/>
+                      <a:round/>
+                      <a:headEnd type="none" w="med" len="med"/>
+                      <a:tailEnd type="none" w="med" len="med"/>
+                    </a:lnB>
+                  </a:tcPr>
+                </a:tc>
+              </a:tr>
+              <a:tr h="713232">
+                <a:tc>
+                  <a:txBody>
+                    <a:bodyPr/>
+                    <a:lstStyle/>
+                    <a:p>
+                      <a:pPr indent="0" marL="0">
+                        <a:buNone/>
+                      </a:pPr>
+                      <a:r>
+                        <a:rPr lang="en-US" sz="1400" b="1" dirty="0">
+                          <a:solidFill>
+                            <a:schemeClr val="tx2"/>
+                          </a:solidFill>
+                        </a:rPr>
+                        <a:t>Logistic regression</a:t>
+                      </a:r>
+                      <a:endParaRPr lang="en-US" sz="1400" dirty="0"/>
+                    </a:p>
+                  </a:txBody>
+                  <a:tcPr marL="101600" marR="101600" marT="38100" marB="38100" anchor="ctr">
+                    <a:lnL w="9525" cap="flat" cmpd="sng" algn="ctr">
+                      <a:solidFill>
+                        <a:srgbClr val="DDE4F0"/>
+                      </a:solidFill>
+                      <a:prstDash val="solid"/>
+                      <a:round/>
+                      <a:headEnd type="none" w="med" len="med"/>
+                      <a:tailEnd type="none" w="med" len="med"/>
+                    </a:lnL>
+                    <a:lnR w="9525" cap="flat" cmpd="sng" algn="ctr">
+                      <a:solidFill>
+                        <a:srgbClr val="DDE4F0"/>
+                      </a:solidFill>
+                      <a:prstDash val="solid"/>
+                      <a:round/>
+                      <a:headEnd type="none" w="med" len="med"/>
+                      <a:tailEnd type="none" w="med" len="med"/>
+                    </a:lnR>
+                    <a:lnT w="9525" cap="flat" cmpd="sng" algn="ctr">
+                      <a:solidFill>
+                        <a:srgbClr val="DDE4F0"/>
+                      </a:solidFill>
+                      <a:prstDash val="solid"/>
+                      <a:round/>
+                      <a:headEnd type="none" w="med" len="med"/>
+                      <a:tailEnd type="none" w="med" len="med"/>
+                    </a:lnT>
+                    <a:lnB w="9525" cap="flat" cmpd="sng" algn="ctr">
+                      <a:solidFill>
+                        <a:srgbClr val="DDE4F0"/>
+                      </a:solidFill>
+                      <a:prstDash val="solid"/>
+                      <a:round/>
+                      <a:headEnd type="none" w="med" len="med"/>
+                      <a:tailEnd type="none" w="med" len="med"/>
+                    </a:lnB>
+                  </a:tcPr>
+                </a:tc>
+                <a:tc>
+                  <a:txBody>
+                    <a:bodyPr/>
+                    <a:lstStyle/>
+                    <a:p>
+                      <a:pPr indent="0" marL="0">
+                        <a:buNone/>
+                      </a:pPr>
+                      <a:r>
+                        <a:rPr lang="en-US" sz="1400" dirty="0">
+                          <a:solidFill>
+                            <a:schemeClr val="tx1"/>
+                          </a:solidFill>
+                        </a:rPr>
+                        <a:t>A simple model: each signal gets a weight; weights add up to a probability</a:t>
+                      </a:r>
+                      <a:endParaRPr lang="en-US" sz="1400" dirty="0"/>
+                    </a:p>
+                  </a:txBody>
+                  <a:tcPr marL="101600" marR="101600" marT="38100" marB="38100" anchor="ctr">
+                    <a:lnL w="9525" cap="flat" cmpd="sng" algn="ctr">
+                      <a:solidFill>
+                        <a:srgbClr val="DDE4F0"/>
+                      </a:solidFill>
+                      <a:prstDash val="solid"/>
+                      <a:round/>
+                      <a:headEnd type="none" w="med" len="med"/>
+                      <a:tailEnd type="none" w="med" len="med"/>
+                    </a:lnL>
+                    <a:lnR w="9525" cap="flat" cmpd="sng" algn="ctr">
+                      <a:solidFill>
+                        <a:srgbClr val="DDE4F0"/>
+                      </a:solidFill>
+                      <a:prstDash val="solid"/>
+                      <a:round/>
+                      <a:headEnd type="none" w="med" len="med"/>
+                      <a:tailEnd type="none" w="med" len="med"/>
+                    </a:lnR>
+                    <a:lnT w="9525" cap="flat" cmpd="sng" algn="ctr">
+                      <a:solidFill>
+                        <a:srgbClr val="DDE4F0"/>
+                      </a:solidFill>
+                      <a:prstDash val="solid"/>
+                      <a:round/>
+                      <a:headEnd type="none" w="med" len="med"/>
+                      <a:tailEnd type="none" w="med" len="med"/>
+                    </a:lnT>
+                    <a:lnB w="9525" cap="flat" cmpd="sng" algn="ctr">
+                      <a:solidFill>
+                        <a:srgbClr val="DDE4F0"/>
+                      </a:solidFill>
+                      <a:prstDash val="solid"/>
+                      <a:round/>
+                      <a:headEnd type="none" w="med" len="med"/>
+                      <a:tailEnd type="none" w="med" len="med"/>
+                    </a:lnB>
+                  </a:tcPr>
+                </a:tc>
+              </a:tr>
+              <a:tr h="713232">
+                <a:tc>
+                  <a:txBody>
+                    <a:bodyPr/>
+                    <a:lstStyle/>
+                    <a:p>
+                      <a:pPr indent="0" marL="0">
+                        <a:buNone/>
+                      </a:pPr>
+                      <a:r>
+                        <a:rPr lang="en-US" sz="1400" b="1" dirty="0">
+                          <a:solidFill>
+                            <a:schemeClr val="tx2"/>
+                          </a:solidFill>
+                        </a:rPr>
+                        <a:t>Row-level security</a:t>
+                      </a:r>
+                      <a:endParaRPr lang="en-US" sz="1400" dirty="0"/>
+                    </a:p>
+                  </a:txBody>
+                  <a:tcPr marL="101600" marR="101600" marT="38100" marB="38100" anchor="ctr">
+                    <a:lnL w="9525" cap="flat" cmpd="sng" algn="ctr">
+                      <a:solidFill>
+                        <a:srgbClr val="DDE4F0"/>
+                      </a:solidFill>
+                      <a:prstDash val="solid"/>
+                      <a:round/>
+                      <a:headEnd type="none" w="med" len="med"/>
+                      <a:tailEnd type="none" w="med" len="med"/>
+                    </a:lnL>
+                    <a:lnR w="9525" cap="flat" cmpd="sng" algn="ctr">
+                      <a:solidFill>
+                        <a:srgbClr val="DDE4F0"/>
+                      </a:solidFill>
+                      <a:prstDash val="solid"/>
+                      <a:round/>
+                      <a:headEnd type="none" w="med" len="med"/>
+                      <a:tailEnd type="none" w="med" len="med"/>
+                    </a:lnR>
+                    <a:lnT w="9525" cap="flat" cmpd="sng" algn="ctr">
+                      <a:solidFill>
+                        <a:srgbClr val="DDE4F0"/>
+                      </a:solidFill>
+                      <a:prstDash val="solid"/>
+                      <a:round/>
+                      <a:headEnd type="none" w="med" len="med"/>
+                      <a:tailEnd type="none" w="med" len="med"/>
+                    </a:lnT>
+                    <a:lnB w="9525" cap="flat" cmpd="sng" algn="ctr">
+                      <a:solidFill>
+                        <a:srgbClr val="DDE4F0"/>
+                      </a:solidFill>
+                      <a:prstDash val="solid"/>
+                      <a:round/>
+                      <a:headEnd type="none" w="med" len="med"/>
+                      <a:tailEnd type="none" w="med" len="med"/>
+                    </a:lnB>
+                  </a:tcPr>
+                </a:tc>
+                <a:tc>
+                  <a:txBody>
+                    <a:bodyPr/>
+                    <a:lstStyle/>
+                    <a:p>
+                      <a:pPr indent="0" marL="0">
+                        <a:buNone/>
+                      </a:pPr>
+                      <a:r>
+                        <a:rPr lang="en-US" sz="1400" dirty="0">
+                          <a:solidFill>
+                            <a:schemeClr val="tx1"/>
+                          </a:solidFill>
+                        </a:rPr>
+                        <a:t>A database feature that hides other companies' rows automatically</a:t>
+                      </a:r>
+                      <a:endParaRPr lang="en-US" sz="1400" dirty="0"/>
+                    </a:p>
+                  </a:txBody>
+                  <a:tcPr marL="101600" marR="101600" marT="38100" marB="38100" anchor="ctr">
+                    <a:lnL w="9525" cap="flat" cmpd="sng" algn="ctr">
+                      <a:solidFill>
+                        <a:srgbClr val="DDE4F0"/>
+                      </a:solidFill>
+                      <a:prstDash val="solid"/>
+                      <a:round/>
+                      <a:headEnd type="none" w="med" len="med"/>
+                      <a:tailEnd type="none" w="med" len="med"/>
+                    </a:lnL>
+                    <a:lnR w="9525" cap="flat" cmpd="sng" algn="ctr">
+                      <a:solidFill>
+                        <a:srgbClr val="DDE4F0"/>
+                      </a:solidFill>
+                      <a:prstDash val="solid"/>
+                      <a:round/>
+                      <a:headEnd type="none" w="med" len="med"/>
+                      <a:tailEnd type="none" w="med" len="med"/>
+                    </a:lnR>
+                    <a:lnT w="9525" cap="flat" cmpd="sng" algn="ctr">
+                      <a:solidFill>
+                        <a:srgbClr val="DDE4F0"/>
+                      </a:solidFill>
+                      <a:prstDash val="solid"/>
+                      <a:round/>
+                      <a:headEnd type="none" w="med" len="med"/>
+                      <a:tailEnd type="none" w="med" len="med"/>
+                    </a:lnT>
+                    <a:lnB w="9525" cap="flat" cmpd="sng" algn="ctr">
+                      <a:solidFill>
+                        <a:srgbClr val="DDE4F0"/>
+                      </a:solidFill>
+                      <a:prstDash val="solid"/>
+                      <a:round/>
+                      <a:headEnd type="none" w="med" len="med"/>
+                      <a:tailEnd type="none" w="med" len="med"/>
+                    </a:lnB>
+                  </a:tcPr>
+                </a:tc>
+              </a:tr>
+            </a:tbl>
+          </a:graphicData>
+        </a:graphic>
+      </p:graphicFrame>
+      <p:sp>
+        <p:nvSpPr>
+          <p:cNvPr id="25" name="Slide Number Placeholder 0"/>
+          <p:cNvSpPr>
+            <a:spLocks noGrp="1"/>
+          </p:cNvSpPr>
+          <p:nvPr>
+            <p:ph type="sldNum" sz="quarter" idx="4294967295"/>
+          </p:nvPr>
+        </p:nvSpPr>
+        <p:spPr>
+          <a:xfrm>
+            <a:off x="11094415" y="6473952"/>
+            <a:ext cx="548640" cy="274320"/>
+          </a:xfrm>
+          <a:prstGeom prst="rect">
+            <a:avLst/>
+          </a:prstGeom>
+          <a:extLst>
+            <a:ext uri="{C572A759-6A51-4108-AA02-DFA0A04FC94B}">
+              <ma14:wrappingTextBoxFlag xmlns:ma14="http://schemas.microsoft.com/office/mac/drawingml/2011/main" val="0"/>
+            </a:ext>
+          </a:extLst>
+        </p:spPr>
+        <p:txBody>
+          <a:bodyPr/>
+          <a:lstStyle>
+            <a:lvl1pPr>
+              <a:defRPr sz="1000">
+                <a:solidFill>
+                  <a:schemeClr val="accent5"/>
+                </a:solidFill>
+              </a:defRPr>
+            </a:lvl1pPr>
+          </a:lstStyle>
+          <a:p>
+            <a:pPr algn="r"/>
+            <a:fld id="{F7021451-1387-4CA6-816F-3879F97B5CBC}" type="slidenum">
+              <a:rPr b="0" lang="en-US"/>
+              <a:t>16</a:t>
+            </a:fld>
+            <a:endParaRPr lang="en-US"/>
+          </a:p>
+        </p:txBody>
+      </p:sp>
+    </p:spTree>
+  </p:cSld>
+  <p:clrMapOvr>
+    <a:masterClrMapping/>
+  </p:clrMapOvr>
+</p:sld>
+</file>
+
+<file path=ppt/slides/slide17.xml><?xml version="1.0" encoding="utf-8"?>
+<p:sld xmlns:a="http://schemas.openxmlformats.org/drawingml/2006/main" xmlns:r="http://schemas.openxmlformats.org/officeDocument/2006/relationships" xmlns:p="http://schemas.openxmlformats.org/presentationml/2006/main">
+  <p:cSld name="Slide 17">
+    <p:spTree>
+      <p:nvGrpSpPr>
+        <p:cNvPr id="1" name=""/>
+        <p:cNvGrpSpPr/>
+        <p:nvPr/>
+      </p:nvGrpSpPr>
+      <p:grpSpPr>
+        <a:xfrm>
+          <a:off x="0" y="0"/>
+          <a:ext cx="0" cy="0"/>
+          <a:chOff x="0" y="0"/>
+          <a:chExt cx="0" cy="0"/>
+        </a:xfrm>
+      </p:grpSpPr>
+      <p:sp>
+        <p:nvSpPr>
+          <p:cNvPr id="2" name="Text 0"/>
+          <p:cNvSpPr/>
+          <p:nvPr>
+            <p:ph idx="100" type="title" hasCustomPrompt="1"/>
+          </p:nvPr>
+        </p:nvSpPr>
+        <p:spPr>
+          <a:xfrm>
             <a:off x="548640" y="411480"/>
             <a:ext cx="11094415" cy="731520"/>
           </a:xfrm>
@@ -10290,7 +12002,7 @@
       </p:sp>
       <p:sp>
         <p:nvSpPr>
-          <p:cNvPr id="3" name="card-296"/>
+          <p:cNvPr id="3" name="card-298"/>
           <p:cNvSpPr/>
           <p:nvPr/>
         </p:nvSpPr>
@@ -10317,7 +12029,7 @@
       </p:sp>
       <p:sp>
         <p:nvSpPr>
-          <p:cNvPr id="4" name="text-297"/>
+          <p:cNvPr id="4" name="text-299"/>
           <p:cNvSpPr txBox="1"/>
           <p:nvPr/>
         </p:nvSpPr>
@@ -10353,7 +12065,7 @@
       </p:sp>
       <p:sp>
         <p:nvSpPr>
-          <p:cNvPr id="5" name="text-298"/>
+          <p:cNvPr id="5" name="text-300"/>
           <p:cNvSpPr txBox="1"/>
           <p:nvPr/>
         </p:nvSpPr>
@@ -10385,7 +12097,7 @@
                   <a:schemeClr val="bg1"/>
                 </a:solidFill>
               </a:rPr>
-              <a:t>Real connectors (synthetic feeds use the same interface)</a:t>
+              <a:t>Live connections to real systems (the synthetic feeds use the same format)</a:t>
             </a:r>
             <a:endParaRPr lang="en-US" sz="1500" dirty="0"/>
           </a:p>
@@ -10403,7 +12115,7 @@
                   <a:schemeClr val="bg1"/>
                 </a:solidFill>
               </a:rPr>
-              <a:t>Sending email, SSO</a:t>
+              <a:t>Sending email; single sign-on</a:t>
             </a:r>
             <a:endParaRPr lang="en-US" sz="1500" dirty="0"/>
           </a:p>
@@ -10439,7 +12151,7 @@
                   <a:schemeClr val="bg1"/>
                 </a:solidFill>
               </a:rPr>
-              <a:t>Review UI for unresolved identities</a:t>
+              <a:t>A screen to resolve unmatched records</a:t>
             </a:r>
             <a:endParaRPr lang="en-US" sz="1500" dirty="0"/>
           </a:p>
@@ -10447,7 +12159,7 @@
       </p:sp>
       <p:sp>
         <p:nvSpPr>
-          <p:cNvPr id="6" name="card-299"/>
+          <p:cNvPr id="6" name="card-301"/>
           <p:cNvSpPr/>
           <p:nvPr/>
         </p:nvSpPr>
@@ -10474,7 +12186,7 @@
       </p:sp>
       <p:sp>
         <p:nvSpPr>
-          <p:cNvPr id="7" name="text-300"/>
+          <p:cNvPr id="7" name="text-302"/>
           <p:cNvSpPr txBox="1"/>
           <p:nvPr/>
         </p:nvSpPr>
@@ -10510,7 +12222,7 @@
       </p:sp>
       <p:sp>
         <p:nvSpPr>
-          <p:cNvPr id="8" name="text-301"/>
+          <p:cNvPr id="8" name="text-303"/>
           <p:cNvSpPr txBox="1"/>
           <p:nvPr/>
         </p:nvSpPr>
@@ -10604,7 +12316,7 @@
       </p:sp>
       <p:sp>
         <p:nvSpPr>
-          <p:cNvPr id="9" name="card-302"/>
+          <p:cNvPr id="9" name="card-304"/>
           <p:cNvSpPr/>
           <p:nvPr/>
         </p:nvSpPr>
@@ -10631,7 +12343,7 @@
       </p:sp>
       <p:sp>
         <p:nvSpPr>
-          <p:cNvPr id="10" name="text-303"/>
+          <p:cNvPr id="10" name="text-305"/>
           <p:cNvSpPr txBox="1"/>
           <p:nvPr/>
         </p:nvSpPr>
@@ -10667,7 +12379,7 @@
       </p:sp>
       <p:sp>
         <p:nvSpPr>
-          <p:cNvPr id="11" name="text-304"/>
+          <p:cNvPr id="11" name="text-306"/>
           <p:cNvSpPr txBox="1"/>
           <p:nvPr/>
         </p:nvSpPr>
@@ -10717,7 +12429,7 @@
                   <a:schemeClr val="bg1"/>
                 </a:solidFill>
               </a:rPr>
-              <a:t>CI: tests and image build on every push</a:t>
+              <a:t>Automatic tests and build on every code push</a:t>
             </a:r>
             <a:endParaRPr lang="en-US" sz="1500" dirty="0"/>
           </a:p>
@@ -10735,7 +12447,7 @@
                   <a:schemeClr val="bg1"/>
                 </a:solidFill>
               </a:rPr>
-              <a:t>Incremental identity matching at 10× scale</a:t>
+              <a:t>Match only new records, for 10× more data</a:t>
             </a:r>
             <a:endParaRPr lang="en-US" sz="1500" dirty="0"/>
           </a:p>
@@ -10753,7 +12465,7 @@
                   <a:schemeClr val="bg1"/>
                 </a:solidFill>
               </a:rPr>
-              <a:t>Retrain on real outcomes; monitor calibration drift</a:t>
+              <a:t>Retrain on real outcomes; watch that percentages stay honest</a:t>
             </a:r>
             <a:endParaRPr lang="en-US" sz="1500" dirty="0"/>
           </a:p>
@@ -10761,7 +12473,7 @@
       </p:sp>
       <p:sp>
         <p:nvSpPr>
-          <p:cNvPr id="12" name="text-305"/>
+          <p:cNvPr id="12" name="text-307"/>
           <p:cNvSpPr txBox="1"/>
           <p:nvPr/>
         </p:nvSpPr>
@@ -10834,7 +12546,7 @@
             <a:pPr algn="r"/>
             <a:fld id="{F7021451-1387-4CA6-816F-3879F97B5CBC}" type="slidenum">
               <a:rPr b="0" lang="en-US"/>
-              <a:t>16</a:t>
+              <a:t>17</a:t>
             </a:fld>
             <a:endParaRPr lang="en-US"/>
           </a:p>
@@ -11361,7 +13073,7 @@
                             <a:schemeClr val="tx1"/>
                           </a:solidFill>
                         </a:rPr>
-                        <a:t>Calibrated chance of not renewing, with the reasons</a:t>
+                        <a:t>Chance of not renewing, with the reasons</a:t>
                       </a:r>
                       <a:endParaRPr lang="en-US" sz="1400" dirty="0"/>
                     </a:p>
@@ -11771,7 +13483,7 @@
                             <a:schemeClr val="accent5"/>
                           </a:solidFill>
                         </a:rPr>
-                        <a:t>At ~10% precision an automatic email spams healthy customers</a:t>
+                        <a:t>At a ~10% hit rate, an automatic email mostly reaches healthy customers</a:t>
                       </a:r>
                       <a:endParaRPr lang="en-US" sz="1400" dirty="0"/>
                     </a:p>
@@ -12505,7 +14217,7 @@
                   <a:schemeClr val="tx1"/>
                 </a:solidFill>
               </a:rPr>
-              <a:t>ROC AUC on held-out renewals</a:t>
+              <a:t>ranking accuracy: how often a churner is ranked above a renewer (0.5 = coin flip)</a:t>
             </a:r>
             <a:endParaRPr lang="en-US" sz="1500" dirty="0"/>
           </a:p>
@@ -12541,7 +14253,7 @@
                   <a:schemeClr val="accent5"/>
                 </a:solidFill>
               </a:rPr>
-              <a:t>Rules 0.59 · gradient boosting 0.73</a:t>
+              <a:t>Rules 0.59</a:t>
             </a:r>
             <a:endParaRPr lang="en-US" sz="1300" dirty="0"/>
           </a:p>
@@ -12761,7 +14473,7 @@
                   <a:schemeClr val="tx1"/>
                 </a:solidFill>
               </a:rPr>
-              <a:t>Precision is 9.4%</a:t>
+              <a:t>Hit rate is 9.4%</a:t>
             </a:r>
             <a:pPr indent="0" marL="0">
               <a:buNone/>
@@ -12772,7 +14484,7 @@
                   <a:schemeClr val="tx1"/>
                 </a:solidFill>
               </a:rPr>
-              <a:t> of call slots, against a perfect-foresight ceiling of 16%: few accounts in any 15-call list actually churn.</a:t>
+              <a:t> of call slots, against 16% with perfect foresight: few accounts in any 15-call list actually churn.</a:t>
             </a:r>
             <a:endParaRPr lang="en-US" sz="1500" dirty="0"/>
           </a:p>
@@ -13127,7 +14839,7 @@
                   <a:schemeClr val="tx1"/>
                 </a:solidFill>
               </a:rPr>
-              <a:t>Brief cites numbered facts (F3, E1)</a:t>
+              <a:t>Each note points to the fact it came from (F3, E1)</a:t>
             </a:r>
             <a:endParaRPr lang="en-US" sz="1400" dirty="0"/>
           </a:p>
@@ -13618,7 +15330,7 @@
                   <a:schemeClr val="tx2"/>
                 </a:solidFill>
               </a:rPr>
-              <a:t>Ingest + identity</a:t>
+              <a:t>Ingest + match</a:t>
             </a:r>
             <a:endParaRPr lang="en-US" sz="1500" dirty="0"/>
           </a:p>
@@ -13654,7 +15366,7 @@
                   <a:schemeClr val="accent5"/>
                 </a:solidFill>
               </a:rPr>
-              <a:t>dedupe, UTC, schema drift, match to accounts</a:t>
+              <a:t>remove duplicates, fix time zones and formats, link records to accounts</a:t>
             </a:r>
             <a:endParaRPr lang="en-US" sz="1200" dirty="0"/>
           </a:p>
@@ -13777,7 +15489,7 @@
                   <a:schemeClr val="accent6"/>
                 </a:solidFill>
               </a:rPr>
-              <a:t>RLS on every tenant table</a:t>
+              <a:t>the database keeps each company's data apart</a:t>
             </a:r>
             <a:endParaRPr lang="en-US" sz="1200" dirty="0"/>
           </a:p>
@@ -14128,7 +15840,7 @@
                             <a:schemeClr val="tx1"/>
                           </a:solidFill>
                         </a:rPr>
-                        <a:t>Python 3.12, FastAPI, psycopg 3, pandas, scikit-learn</a:t>
+                        <a:t>Python 3.12, FastAPI, pandas, scikit-learn</a:t>
                       </a:r>
                       <a:endParaRPr lang="en-US" sz="1400" dirty="0"/>
                     </a:p>
@@ -14246,7 +15958,7 @@
                             <a:schemeClr val="tx1"/>
                           </a:solidFill>
                         </a:rPr>
-                        <a:t>Postgres 16: row-level security, plain ordered SQL migrations</a:t>
+                        <a:t>Postgres 16, with per-company data isolation built into the database</a:t>
                       </a:r>
                       <a:endParaRPr lang="en-US" sz="1400" dirty="0"/>
                     </a:p>
@@ -14600,7 +16312,7 @@
                             <a:schemeClr val="tx1"/>
                           </a:solidFill>
                         </a:rPr>
-                        <a:t>Docker Compose on one EC2: db · api · scheduler · caddy (TLS)</a:t>
+                        <a:t>Docker Compose on one AWS server: database, app, scheduler, HTTPS proxy</a:t>
                       </a:r>
                       <a:endParaRPr lang="en-US" sz="1400" dirty="0"/>
                     </a:p>
@@ -14718,7 +16430,7 @@
                             <a:schemeClr val="tx1"/>
                           </a:solidFill>
                         </a:rPr>
-                        <a:t>OpenTelemetry, JSON logs with trace_id, API audit table</a:t>
+                        <a:t>Structured logs; every request has an ID that links it to its log lines</a:t>
                       </a:r>
                       <a:endParaRPr lang="en-US" sz="1400" dirty="0"/>
                     </a:p>
@@ -15671,7 +17383,7 @@
                             <a:schemeClr val="tx1"/>
                           </a:solidFill>
                         </a:rPr>
-                        <a:t>Three-level idempotency: file, record hash, semantic key</a:t>
+                        <a:t>Checked at three levels (file, exact copy, same event), so reloading changes nothing</a:t>
                       </a:r>
                       <a:endParaRPr lang="en-US" sz="1300" dirty="0"/>
                     </a:p>
@@ -15789,7 +17501,7 @@
                             <a:schemeClr val="tx1"/>
                           </a:solidFill>
                         </a:rPr>
-                        <a:t>Files by arrival date; every row keeps arrived_at; features are point-in-time</a:t>
+                        <a:t>Every record keeps when it arrived; a score only uses data that had arrived by its date</a:t>
                       </a:r>
                       <a:endParaRPr lang="en-US" sz="1300" dirty="0"/>
                     </a:p>
@@ -15907,7 +17619,7 @@
                             <a:schemeClr val="tx1"/>
                           </a:solidFill>
                         </a:rPr>
-                        <a:t>Per-source parsers normalise to UTC and one schema</a:t>
+                        <a:t>Each source is converted to one time zone (UTC) and one format</a:t>
                       </a:r>
                       <a:endParaRPr lang="en-US" sz="1300" dirty="0"/>
                     </a:p>
@@ -16025,7 +17737,7 @@
                             <a:schemeClr val="tx1"/>
                           </a:solidFill>
                         </a:rPr>
-                        <a:t>Match cascade (explicit id → email → domain → fuzzy ≥92); else unresolved, never guessed. 2 wrong out of ~14k checked</a:t>
+                        <a:t>Matched by ID, then email, then domain, then a close name match; if unsure, left for review. 2 wrong out of ~14k checked</a:t>
                       </a:r>
                       <a:endParaRPr lang="en-US" sz="1300" dirty="0"/>
                     </a:p>
@@ -16450,7 +18162,7 @@
                   <a:schemeClr val="accent5"/>
                 </a:solidFill>
               </a:rPr>
-              <a:t>26 tables in five layers. tenant_id on every row; facts are append-only, decisions reference the run that made them</a:t>
+              <a:t>26 tables in five layers. Every row is tagged with its company; history is added to, never overwritten</a:t>
             </a:r>
             <a:endParaRPr lang="en-US" sz="1600" dirty="0"/>
           </a:p>
@@ -17391,7 +19103,7 @@
                   <a:schemeClr val="tx2"/>
                 </a:solidFill>
               </a:rPr>
-              <a:t>Point in time</a:t>
+              <a:t>Replayable</a:t>
             </a:r>
             <a:endParaRPr lang="en-US" sz="1500" dirty="0"/>
           </a:p>
@@ -17427,7 +19139,7 @@
                   <a:schemeClr val="tx1"/>
                 </a:solidFill>
               </a:rPr>
-              <a:t>Every normalised row keeps event time and arrived_at; CRM changes are stored as versions, never overwritten</a:t>
+              <a:t>Every record keeps when it happened and when it arrived; CRM changes are kept as versions</a:t>
             </a:r>
             <a:endParaRPr lang="en-US" sz="1300" dirty="0"/>
           </a:p>
@@ -17560,7 +19272,7 @@
                   <a:schemeClr val="tx1"/>
                 </a:solidFill>
               </a:rPr>
-              <a:t>Each score row stores run_id and model_version; the run stores the exact feature values it used</a:t>
+              <a:t>Each score records which run and model version produced it, and the exact inputs used</a:t>
             </a:r>
             <a:endParaRPr lang="en-US" sz="1300" dirty="0"/>
           </a:p>
@@ -17693,7 +19405,7 @@
                   <a:schemeClr val="tx1"/>
                 </a:solidFill>
               </a:rPr>
-              <a:t>Postgres row-level security is forced on every tenant table; with no tenant set, queries return nothing</a:t>
+              <a:t>The database itself hides other companies' rows; if no company is set, it returns nothing</a:t>
             </a:r>
             <a:endParaRPr lang="en-US" sz="1300" dirty="0"/>
           </a:p>
@@ -17902,7 +19614,7 @@
                   <a:schemeClr val="tx2"/>
                 </a:solidFill>
               </a:rPr>
-              <a:t>Point-in-time snapshot: 24 signals</a:t>
+              <a:t>A snapshot of 24 signals, as of the scoring date</a:t>
             </a:r>
             <a:endParaRPr lang="en-US" sz="1700" dirty="0"/>
           </a:p>
@@ -17938,7 +19650,7 @@
                   <a:schemeClr val="accent5"/>
                 </a:solidFill>
               </a:rPr>
-              <a:t>Uses only rows with event_time &lt; as_of and arrived_at ≤ as_of</a:t>
+              <a:t>Only data that had happened and had arrived by that date: no peeking at the future</a:t>
             </a:r>
             <a:endParaRPr lang="en-US" sz="1300" dirty="0"/>
           </a:p>
@@ -18581,7 +20293,7 @@
                   <a:schemeClr val="bg1"/>
                 </a:solidFill>
               </a:rPr>
-              <a:t>p_churn</a:t>
+              <a:t>Risk</a:t>
             </a:r>
             <a:pPr indent="0" marL="0">
               <a:buNone/>
@@ -18592,7 +20304,7 @@
                   <a:schemeClr val="bg1"/>
                 </a:solidFill>
               </a:rPr>
-              <a:t>: calibrated chance of not renewing</a:t>
+              <a:t>: chance of not renewing, e.g. 26%</a:t>
             </a:r>
             <a:endParaRPr lang="en-US" sz="1400" dirty="0"/>
           </a:p>
@@ -18610,7 +20322,7 @@
                   <a:schemeClr val="bg1"/>
                 </a:solidFill>
               </a:rPr>
-              <a:t>drivers</a:t>
+              <a:t>Reasons</a:t>
             </a:r>
             <a:pPr indent="0" marL="0">
               <a:buNone/>
@@ -18621,7 +20333,7 @@
                   <a:schemeClr val="bg1"/>
                 </a:solidFill>
               </a:rPr>
-              <a:t>: exact per-account contributions</a:t>
+              <a:t>: how much each signal raised or lowered it</a:t>
             </a:r>
             <a:endParaRPr lang="en-US" sz="1400" dirty="0"/>
           </a:p>
@@ -18639,7 +20351,7 @@
                   <a:schemeClr val="bg1"/>
                 </a:solidFill>
               </a:rPr>
-              <a:t>changes</a:t>
+              <a:t>What changed</a:t>
             </a:r>
             <a:pPr indent="0" marL="0">
               <a:buNone/>
@@ -18650,7 +20362,7 @@
                   <a:schemeClr val="bg1"/>
                 </a:solidFill>
               </a:rPr>
-              <a:t>: diff against the previous run</a:t>
+              <a:t> since the previous run</a:t>
             </a:r>
             <a:endParaRPr lang="en-US" sz="1400" dirty="0"/>
           </a:p>
@@ -18668,7 +20380,7 @@
                   <a:schemeClr val="bg1"/>
                 </a:solidFill>
               </a:rPr>
-              <a:t>coverage</a:t>
+              <a:t>Coverage</a:t>
             </a:r>
             <a:pPr indent="0" marL="0">
               <a:buNone/>
@@ -18697,7 +20409,7 @@
                   <a:schemeClr val="bg1"/>
                 </a:solidFill>
               </a:rPr>
-              <a:t>priority, band, rank</a:t>
+              <a:t>Priority, colour, rank</a:t>
             </a:r>
             <a:pPr indent="0" marL="0">
               <a:buNone/>
@@ -18708,7 +20420,7 @@
                   <a:schemeClr val="bg1"/>
                 </a:solidFill>
               </a:rPr>
-              <a:t> + run_id, model_version</a:t>
+              <a:t> + which run and model made it</a:t>
             </a:r>
             <a:endParaRPr lang="en-US" sz="1400" dirty="0"/>
           </a:p>
@@ -18906,7 +20618,7 @@
                   <a:schemeClr val="accent5"/>
                 </a:solidFill>
               </a:rPr>
-              <a:t>risk ≥ 2× base rate</a:t>
+              <a:t>risk at least 2× the average</a:t>
             </a:r>
             <a:endParaRPr lang="en-US" sz="1300" dirty="0"/>
           </a:p>
@@ -19516,7 +21228,7 @@
                   <a:schemeClr val="tx1"/>
                 </a:solidFill>
               </a:rPr>
-              <a:t>29,000+ snapshots taken 28, 56, 84 and 112 days before each past renewal, point-in-time</a:t>
+              <a:t>29,000+ snapshots taken 1–4 months before each past renewal, using only what was known then</a:t>
             </a:r>
             <a:endParaRPr lang="en-US" sz="1400" dirty="0"/>
           </a:p>
@@ -19649,7 +21361,7 @@
                   <a:schemeClr val="tx1"/>
                 </a:solidFill>
               </a:rPr>
-              <a:t>Logistic regression with sign constraints: a signal whose weight points the wrong way is dropped and the model refit</a:t>
+              <a:t>Logistic regression (each signal gets a weight; weights add up to a probability). A signal that pushes the wrong way, e.g. more usage = more risk, is removed</a:t>
             </a:r>
             <a:endParaRPr lang="en-US" sz="1400" dirty="0"/>
           </a:p>
@@ -19782,7 +21494,7 @@
                   <a:schemeClr val="tx1"/>
                 </a:solidFill>
               </a:rPr>
-              <a:t>One model pooled across companies, then calibrated per company (the smallest has ~100 renewals)</a:t>
+              <a:t>One model learns from all companies, then its percentages are adjusted per company (the smallest has only ~100 renewals)</a:t>
             </a:r>
             <a:endParaRPr lang="en-US" sz="1400" dirty="0"/>
           </a:p>
@@ -20009,14 +21721,14 @@
               <a:buNone/>
             </a:pPr>
             <a:r>
-              <a:rPr lang="en-US" sz="2200" b="1" dirty="0">
+              <a:rPr lang="en-US" sz="1600" b="1" dirty="0">
                 <a:solidFill>
                   <a:schemeClr val="bg1"/>
                 </a:solidFill>
               </a:rPr>
-              <a:t>priority = p × √ARR × urgency</a:t>
-            </a:r>
-            <a:endParaRPr lang="en-US" sz="2200" dirty="0"/>
+              <a:t>priority = risk × √revenue × urgency</a:t>
+            </a:r>
+            <a:endParaRPr lang="en-US" sz="1600" dirty="0"/>
           </a:p>
         </p:txBody>
       </p:sp>
@@ -20054,7 +21766,7 @@
                   <a:schemeClr val="bg1"/>
                 </a:solidFill>
               </a:rPr>
-              <a:t>√ARR: a $500k account can't bury every $20k account</a:t>
+              <a:t>√revenue: a $500k account can't bury every $20k account</a:t>
             </a:r>
             <a:endParaRPr lang="en-US" sz="1300" dirty="0"/>
           </a:p>
@@ -20090,7 +21802,7 @@
                   <a:schemeClr val="bg1"/>
                 </a:solidFill>
               </a:rPr>
-              <a:t>Days-to-renewal is kept out of the model to avoid counting it twice</a:t>
+              <a:t>Renewal timing is left out of the model so it isn't counted twice</a:t>
             </a:r>
             <a:endParaRPr lang="en-US" sz="1300" dirty="0"/>
           </a:p>

</xml_diff>